<commit_message>
update com funcao de distancia mais eficiente
</commit_message>
<xml_diff>
--- a/validacao.pptx
+++ b/validacao.pptx
@@ -7,10 +7,6 @@
   <p:sldIdLst>
     <p:sldId id="256" r:id="rId2"/>
     <p:sldId id="257" r:id="rId3"/>
-    <p:sldId id="258" r:id="rId4"/>
-    <p:sldId id="259" r:id="rId5"/>
-    <p:sldId id="260" r:id="rId6"/>
-    <p:sldId id="261" r:id="rId7"/>
   </p:sldIdLst>
   <p:sldSz cx="12192000" cy="6858000"/>
   <p:notesSz cx="6858000" cy="9144000"/>
@@ -109,19 +105,154 @@
       </a:defRPr>
     </a:lvl9pPr>
   </p:defaultTextStyle>
+  <p:extLst>
+    <p:ext uri="{EFAFB233-063F-42B5-8137-9DF3F51BA10A}">
+      <p15:sldGuideLst xmlns:p15="http://schemas.microsoft.com/office/powerpoint/2012/main"/>
+    </p:ext>
+  </p:extLst>
 </p:presentation>
 </file>
 
 <file path=ppt/revisionInfo.xml><?xml version="1.0" encoding="utf-8"?>
 <p1510:revInfo xmlns:a="http://schemas.openxmlformats.org/drawingml/2006/main" xmlns:r="http://schemas.openxmlformats.org/officeDocument/2006/relationships" xmlns:p1510="http://schemas.microsoft.com/office/powerpoint/2015/10/main">
   <p1510:revLst>
-    <p1510:client id="{397B3CA5-8420-4BB2-A10F-11EC221A7B9F}" v="1" dt="2025-05-31T21:31:12.832"/>
+    <p1510:client id="{1B3C1AB0-C923-4ABF-904D-B74B091EEBB6}" v="2" dt="2025-06-27T23:12:46.180"/>
   </p1510:revLst>
 </p1510:revInfo>
 </file>
 
 <file path=ppt/changesInfos/changesInfo1.xml><?xml version="1.0" encoding="utf-8"?>
 <pc:chgInfo xmlns:a="http://schemas.openxmlformats.org/drawingml/2006/main" xmlns:r="http://schemas.openxmlformats.org/officeDocument/2006/relationships" xmlns:ac="http://schemas.microsoft.com/office/drawing/2013/main/command" xmlns:pc="http://schemas.microsoft.com/office/powerpoint/2013/main/command">
+  <pc:docChgLst>
+    <pc:chgData name="Tiago Beltrao Lacerda" userId="a6cfa6f6-6314-4baf-b142-94e6e4254abd" providerId="ADAL" clId="{1B3C1AB0-C923-4ABF-904D-B74B091EEBB6}"/>
+    <pc:docChg chg="custSel addSld delSld modSld">
+      <pc:chgData name="Tiago Beltrao Lacerda" userId="a6cfa6f6-6314-4baf-b142-94e6e4254abd" providerId="ADAL" clId="{1B3C1AB0-C923-4ABF-904D-B74B091EEBB6}" dt="2025-06-27T23:13:16.088" v="54" actId="478"/>
+      <pc:docMkLst>
+        <pc:docMk/>
+      </pc:docMkLst>
+      <pc:sldChg chg="addSp delSp modSp mod">
+        <pc:chgData name="Tiago Beltrao Lacerda" userId="a6cfa6f6-6314-4baf-b142-94e6e4254abd" providerId="ADAL" clId="{1B3C1AB0-C923-4ABF-904D-B74B091EEBB6}" dt="2025-06-27T23:12:56.086" v="34" actId="20577"/>
+        <pc:sldMkLst>
+          <pc:docMk/>
+          <pc:sldMk cId="2847733816" sldId="256"/>
+        </pc:sldMkLst>
+        <pc:spChg chg="mod">
+          <ac:chgData name="Tiago Beltrao Lacerda" userId="a6cfa6f6-6314-4baf-b142-94e6e4254abd" providerId="ADAL" clId="{1B3C1AB0-C923-4ABF-904D-B74B091EEBB6}" dt="2025-06-27T23:12:56.086" v="34" actId="20577"/>
+          <ac:spMkLst>
+            <pc:docMk/>
+            <pc:sldMk cId="2847733816" sldId="256"/>
+            <ac:spMk id="12" creationId="{30D9C246-5ED4-BEE0-44EC-5B8C3B3134FB}"/>
+          </ac:spMkLst>
+        </pc:spChg>
+        <pc:graphicFrameChg chg="add del mod">
+          <ac:chgData name="Tiago Beltrao Lacerda" userId="a6cfa6f6-6314-4baf-b142-94e6e4254abd" providerId="ADAL" clId="{1B3C1AB0-C923-4ABF-904D-B74B091EEBB6}" dt="2025-06-27T23:12:43.570" v="5" actId="478"/>
+          <ac:graphicFrameMkLst>
+            <pc:docMk/>
+            <pc:sldMk cId="2847733816" sldId="256"/>
+            <ac:graphicFrameMk id="2" creationId="{08400E03-E2EB-2719-F24A-295674613EF4}"/>
+          </ac:graphicFrameMkLst>
+        </pc:graphicFrameChg>
+        <pc:graphicFrameChg chg="add mod">
+          <ac:chgData name="Tiago Beltrao Lacerda" userId="a6cfa6f6-6314-4baf-b142-94e6e4254abd" providerId="ADAL" clId="{1B3C1AB0-C923-4ABF-904D-B74B091EEBB6}" dt="2025-06-27T23:12:50.204" v="7" actId="1076"/>
+          <ac:graphicFrameMkLst>
+            <pc:docMk/>
+            <pc:sldMk cId="2847733816" sldId="256"/>
+            <ac:graphicFrameMk id="3" creationId="{FB427889-2CB8-1D9C-6062-EA109112BEDE}"/>
+          </ac:graphicFrameMkLst>
+        </pc:graphicFrameChg>
+        <pc:picChg chg="del">
+          <ac:chgData name="Tiago Beltrao Lacerda" userId="a6cfa6f6-6314-4baf-b142-94e6e4254abd" providerId="ADAL" clId="{1B3C1AB0-C923-4ABF-904D-B74B091EEBB6}" dt="2025-06-27T23:12:38.175" v="1" actId="478"/>
+          <ac:picMkLst>
+            <pc:docMk/>
+            <pc:sldMk cId="2847733816" sldId="256"/>
+            <ac:picMk id="5" creationId="{4A606BF5-CEA1-76AC-E0E8-0B1C3179FAC9}"/>
+          </ac:picMkLst>
+        </pc:picChg>
+        <pc:picChg chg="del">
+          <ac:chgData name="Tiago Beltrao Lacerda" userId="a6cfa6f6-6314-4baf-b142-94e6e4254abd" providerId="ADAL" clId="{1B3C1AB0-C923-4ABF-904D-B74B091EEBB6}" dt="2025-06-27T23:12:39.304" v="3" actId="478"/>
+          <ac:picMkLst>
+            <pc:docMk/>
+            <pc:sldMk cId="2847733816" sldId="256"/>
+            <ac:picMk id="7" creationId="{222C6AEA-2F4C-ACF5-49DF-7544004C037C}"/>
+          </ac:picMkLst>
+        </pc:picChg>
+        <pc:picChg chg="del">
+          <ac:chgData name="Tiago Beltrao Lacerda" userId="a6cfa6f6-6314-4baf-b142-94e6e4254abd" providerId="ADAL" clId="{1B3C1AB0-C923-4ABF-904D-B74B091EEBB6}" dt="2025-06-27T23:12:38.701" v="2" actId="478"/>
+          <ac:picMkLst>
+            <pc:docMk/>
+            <pc:sldMk cId="2847733816" sldId="256"/>
+            <ac:picMk id="9" creationId="{EA0ED04D-C8EF-2F4A-D590-4F5C63283895}"/>
+          </ac:picMkLst>
+        </pc:picChg>
+        <pc:picChg chg="del">
+          <ac:chgData name="Tiago Beltrao Lacerda" userId="a6cfa6f6-6314-4baf-b142-94e6e4254abd" providerId="ADAL" clId="{1B3C1AB0-C923-4ABF-904D-B74B091EEBB6}" dt="2025-06-27T23:12:38.175" v="1" actId="478"/>
+          <ac:picMkLst>
+            <pc:docMk/>
+            <pc:sldMk cId="2847733816" sldId="256"/>
+            <ac:picMk id="11" creationId="{1614B37E-9D45-5B6F-7405-1254833078E3}"/>
+          </ac:picMkLst>
+        </pc:picChg>
+      </pc:sldChg>
+      <pc:sldChg chg="del">
+        <pc:chgData name="Tiago Beltrao Lacerda" userId="a6cfa6f6-6314-4baf-b142-94e6e4254abd" providerId="ADAL" clId="{1B3C1AB0-C923-4ABF-904D-B74B091EEBB6}" dt="2025-06-27T23:12:35.538" v="0" actId="47"/>
+        <pc:sldMkLst>
+          <pc:docMk/>
+          <pc:sldMk cId="1106815609" sldId="257"/>
+        </pc:sldMkLst>
+      </pc:sldChg>
+      <pc:sldChg chg="delSp modSp add mod">
+        <pc:chgData name="Tiago Beltrao Lacerda" userId="a6cfa6f6-6314-4baf-b142-94e6e4254abd" providerId="ADAL" clId="{1B3C1AB0-C923-4ABF-904D-B74B091EEBB6}" dt="2025-06-27T23:13:16.088" v="54" actId="478"/>
+        <pc:sldMkLst>
+          <pc:docMk/>
+          <pc:sldMk cId="3310696631" sldId="257"/>
+        </pc:sldMkLst>
+        <pc:spChg chg="mod">
+          <ac:chgData name="Tiago Beltrao Lacerda" userId="a6cfa6f6-6314-4baf-b142-94e6e4254abd" providerId="ADAL" clId="{1B3C1AB0-C923-4ABF-904D-B74B091EEBB6}" dt="2025-06-27T23:13:11.341" v="53" actId="20577"/>
+          <ac:spMkLst>
+            <pc:docMk/>
+            <pc:sldMk cId="3310696631" sldId="257"/>
+            <ac:spMk id="12" creationId="{B3E37C0C-FA0B-D742-8A9D-D1E22F0302D6}"/>
+          </ac:spMkLst>
+        </pc:spChg>
+        <pc:graphicFrameChg chg="del">
+          <ac:chgData name="Tiago Beltrao Lacerda" userId="a6cfa6f6-6314-4baf-b142-94e6e4254abd" providerId="ADAL" clId="{1B3C1AB0-C923-4ABF-904D-B74B091EEBB6}" dt="2025-06-27T23:13:16.088" v="54" actId="478"/>
+          <ac:graphicFrameMkLst>
+            <pc:docMk/>
+            <pc:sldMk cId="3310696631" sldId="257"/>
+            <ac:graphicFrameMk id="3" creationId="{5981DF8E-429D-97FE-D522-C2BD7B90A9F1}"/>
+          </ac:graphicFrameMkLst>
+        </pc:graphicFrameChg>
+      </pc:sldChg>
+      <pc:sldChg chg="del">
+        <pc:chgData name="Tiago Beltrao Lacerda" userId="a6cfa6f6-6314-4baf-b142-94e6e4254abd" providerId="ADAL" clId="{1B3C1AB0-C923-4ABF-904D-B74B091EEBB6}" dt="2025-06-27T23:12:35.538" v="0" actId="47"/>
+        <pc:sldMkLst>
+          <pc:docMk/>
+          <pc:sldMk cId="3804799167" sldId="258"/>
+        </pc:sldMkLst>
+      </pc:sldChg>
+      <pc:sldChg chg="del">
+        <pc:chgData name="Tiago Beltrao Lacerda" userId="a6cfa6f6-6314-4baf-b142-94e6e4254abd" providerId="ADAL" clId="{1B3C1AB0-C923-4ABF-904D-B74B091EEBB6}" dt="2025-06-27T23:12:35.538" v="0" actId="47"/>
+        <pc:sldMkLst>
+          <pc:docMk/>
+          <pc:sldMk cId="855907889" sldId="259"/>
+        </pc:sldMkLst>
+      </pc:sldChg>
+      <pc:sldChg chg="del">
+        <pc:chgData name="Tiago Beltrao Lacerda" userId="a6cfa6f6-6314-4baf-b142-94e6e4254abd" providerId="ADAL" clId="{1B3C1AB0-C923-4ABF-904D-B74B091EEBB6}" dt="2025-06-27T23:12:35.538" v="0" actId="47"/>
+        <pc:sldMkLst>
+          <pc:docMk/>
+          <pc:sldMk cId="652017484" sldId="260"/>
+        </pc:sldMkLst>
+      </pc:sldChg>
+      <pc:sldChg chg="del">
+        <pc:chgData name="Tiago Beltrao Lacerda" userId="a6cfa6f6-6314-4baf-b142-94e6e4254abd" providerId="ADAL" clId="{1B3C1AB0-C923-4ABF-904D-B74B091EEBB6}" dt="2025-06-27T23:12:35.538" v="0" actId="47"/>
+        <pc:sldMkLst>
+          <pc:docMk/>
+          <pc:sldMk cId="2899868402" sldId="261"/>
+        </pc:sldMkLst>
+      </pc:sldChg>
+    </pc:docChg>
+  </pc:docChgLst>
   <pc:docChgLst>
     <pc:chgData name="Tiago Beltrao Lacerda" userId="a6cfa6f6-6314-4baf-b142-94e6e4254abd" providerId="ADAL" clId="{397B3CA5-8420-4BB2-A10F-11EC221A7B9F}"/>
     <pc:docChg chg="undo custSel addSld modSld">
@@ -135,22 +266,6 @@
           <pc:docMk/>
           <pc:sldMk cId="2847733816" sldId="256"/>
         </pc:sldMkLst>
-        <pc:spChg chg="del">
-          <ac:chgData name="Tiago Beltrao Lacerda" userId="a6cfa6f6-6314-4baf-b142-94e6e4254abd" providerId="ADAL" clId="{397B3CA5-8420-4BB2-A10F-11EC221A7B9F}" dt="2025-05-31T21:29:41.854" v="1" actId="478"/>
-          <ac:spMkLst>
-            <pc:docMk/>
-            <pc:sldMk cId="2847733816" sldId="256"/>
-            <ac:spMk id="2" creationId="{B7515201-39A7-4EED-9D1D-E54F33B6B292}"/>
-          </ac:spMkLst>
-        </pc:spChg>
-        <pc:spChg chg="del">
-          <ac:chgData name="Tiago Beltrao Lacerda" userId="a6cfa6f6-6314-4baf-b142-94e6e4254abd" providerId="ADAL" clId="{397B3CA5-8420-4BB2-A10F-11EC221A7B9F}" dt="2025-05-31T21:29:41.854" v="1" actId="478"/>
-          <ac:spMkLst>
-            <pc:docMk/>
-            <pc:sldMk cId="2847733816" sldId="256"/>
-            <ac:spMk id="3" creationId="{12A603FB-2E76-E3DC-CD05-8E0DA3383EEB}"/>
-          </ac:spMkLst>
-        </pc:spChg>
         <pc:spChg chg="add mod">
           <ac:chgData name="Tiago Beltrao Lacerda" userId="a6cfa6f6-6314-4baf-b142-94e6e4254abd" providerId="ADAL" clId="{397B3CA5-8420-4BB2-A10F-11EC221A7B9F}" dt="2025-05-31T21:31:19.948" v="30" actId="113"/>
           <ac:spMkLst>
@@ -159,38 +274,6 @@
             <ac:spMk id="12" creationId="{30D9C246-5ED4-BEE0-44EC-5B8C3B3134FB}"/>
           </ac:spMkLst>
         </pc:spChg>
-        <pc:picChg chg="add mod">
-          <ac:chgData name="Tiago Beltrao Lacerda" userId="a6cfa6f6-6314-4baf-b142-94e6e4254abd" providerId="ADAL" clId="{397B3CA5-8420-4BB2-A10F-11EC221A7B9F}" dt="2025-05-31T21:31:04.382" v="19" actId="1076"/>
-          <ac:picMkLst>
-            <pc:docMk/>
-            <pc:sldMk cId="2847733816" sldId="256"/>
-            <ac:picMk id="5" creationId="{4A606BF5-CEA1-76AC-E0E8-0B1C3179FAC9}"/>
-          </ac:picMkLst>
-        </pc:picChg>
-        <pc:picChg chg="add mod">
-          <ac:chgData name="Tiago Beltrao Lacerda" userId="a6cfa6f6-6314-4baf-b142-94e6e4254abd" providerId="ADAL" clId="{397B3CA5-8420-4BB2-A10F-11EC221A7B9F}" dt="2025-05-31T21:31:02.677" v="18" actId="1076"/>
-          <ac:picMkLst>
-            <pc:docMk/>
-            <pc:sldMk cId="2847733816" sldId="256"/>
-            <ac:picMk id="7" creationId="{222C6AEA-2F4C-ACF5-49DF-7544004C037C}"/>
-          </ac:picMkLst>
-        </pc:picChg>
-        <pc:picChg chg="add mod">
-          <ac:chgData name="Tiago Beltrao Lacerda" userId="a6cfa6f6-6314-4baf-b142-94e6e4254abd" providerId="ADAL" clId="{397B3CA5-8420-4BB2-A10F-11EC221A7B9F}" dt="2025-05-31T21:31:00.171" v="17" actId="1076"/>
-          <ac:picMkLst>
-            <pc:docMk/>
-            <pc:sldMk cId="2847733816" sldId="256"/>
-            <ac:picMk id="9" creationId="{EA0ED04D-C8EF-2F4A-D590-4F5C63283895}"/>
-          </ac:picMkLst>
-        </pc:picChg>
-        <pc:picChg chg="add mod">
-          <ac:chgData name="Tiago Beltrao Lacerda" userId="a6cfa6f6-6314-4baf-b142-94e6e4254abd" providerId="ADAL" clId="{397B3CA5-8420-4BB2-A10F-11EC221A7B9F}" dt="2025-05-31T21:31:06.157" v="20" actId="1076"/>
-          <ac:picMkLst>
-            <pc:docMk/>
-            <pc:sldMk cId="2847733816" sldId="256"/>
-            <ac:picMk id="11" creationId="{1614B37E-9D45-5B6F-7405-1254833078E3}"/>
-          </ac:picMkLst>
-        </pc:picChg>
       </pc:sldChg>
       <pc:sldChg chg="addSp delSp modSp add mod">
         <pc:chgData name="Tiago Beltrao Lacerda" userId="a6cfa6f6-6314-4baf-b142-94e6e4254abd" providerId="ADAL" clId="{397B3CA5-8420-4BB2-A10F-11EC221A7B9F}" dt="2025-06-01T15:04:51.617" v="108" actId="20577"/>
@@ -198,94 +281,6 @@
           <pc:docMk/>
           <pc:sldMk cId="1106815609" sldId="257"/>
         </pc:sldMkLst>
-        <pc:spChg chg="add del">
-          <ac:chgData name="Tiago Beltrao Lacerda" userId="a6cfa6f6-6314-4baf-b142-94e6e4254abd" providerId="ADAL" clId="{397B3CA5-8420-4BB2-A10F-11EC221A7B9F}" dt="2025-05-31T21:32:29.004" v="49" actId="22"/>
-          <ac:spMkLst>
-            <pc:docMk/>
-            <pc:sldMk cId="1106815609" sldId="257"/>
-            <ac:spMk id="3" creationId="{EAA981A1-115E-6F8B-A496-AB024E18364A}"/>
-          </ac:spMkLst>
-        </pc:spChg>
-        <pc:spChg chg="mod">
-          <ac:chgData name="Tiago Beltrao Lacerda" userId="a6cfa6f6-6314-4baf-b142-94e6e4254abd" providerId="ADAL" clId="{397B3CA5-8420-4BB2-A10F-11EC221A7B9F}" dt="2025-06-01T15:04:51.617" v="108" actId="20577"/>
-          <ac:spMkLst>
-            <pc:docMk/>
-            <pc:sldMk cId="1106815609" sldId="257"/>
-            <ac:spMk id="12" creationId="{477CF272-1685-99F2-10F7-D101D1C64A9F}"/>
-          </ac:spMkLst>
-        </pc:spChg>
-        <pc:picChg chg="del">
-          <ac:chgData name="Tiago Beltrao Lacerda" userId="a6cfa6f6-6314-4baf-b142-94e6e4254abd" providerId="ADAL" clId="{397B3CA5-8420-4BB2-A10F-11EC221A7B9F}" dt="2025-05-31T21:31:27.439" v="35" actId="478"/>
-          <ac:picMkLst>
-            <pc:docMk/>
-            <pc:sldMk cId="1106815609" sldId="257"/>
-            <ac:picMk id="5" creationId="{621F11F2-BE39-B351-7D29-F9CE1369A248}"/>
-          </ac:picMkLst>
-        </pc:picChg>
-        <pc:picChg chg="add mod">
-          <ac:chgData name="Tiago Beltrao Lacerda" userId="a6cfa6f6-6314-4baf-b142-94e6e4254abd" providerId="ADAL" clId="{397B3CA5-8420-4BB2-A10F-11EC221A7B9F}" dt="2025-05-31T21:32:40.575" v="51" actId="1076"/>
-          <ac:picMkLst>
-            <pc:docMk/>
-            <pc:sldMk cId="1106815609" sldId="257"/>
-            <ac:picMk id="6" creationId="{F3BACFF8-DA07-128D-AFFE-DD7273025582}"/>
-          </ac:picMkLst>
-        </pc:picChg>
-        <pc:picChg chg="del">
-          <ac:chgData name="Tiago Beltrao Lacerda" userId="a6cfa6f6-6314-4baf-b142-94e6e4254abd" providerId="ADAL" clId="{397B3CA5-8420-4BB2-A10F-11EC221A7B9F}" dt="2025-05-31T21:31:27.096" v="34" actId="478"/>
-          <ac:picMkLst>
-            <pc:docMk/>
-            <pc:sldMk cId="1106815609" sldId="257"/>
-            <ac:picMk id="7" creationId="{809BF5A6-D3EA-64FB-EF46-AE52D7964D5D}"/>
-          </ac:picMkLst>
-        </pc:picChg>
-        <pc:picChg chg="del">
-          <ac:chgData name="Tiago Beltrao Lacerda" userId="a6cfa6f6-6314-4baf-b142-94e6e4254abd" providerId="ADAL" clId="{397B3CA5-8420-4BB2-A10F-11EC221A7B9F}" dt="2025-05-31T21:31:26.319" v="33" actId="478"/>
-          <ac:picMkLst>
-            <pc:docMk/>
-            <pc:sldMk cId="1106815609" sldId="257"/>
-            <ac:picMk id="9" creationId="{93378616-54EC-43D1-C5EB-93E53551DB66}"/>
-          </ac:picMkLst>
-        </pc:picChg>
-        <pc:picChg chg="add mod">
-          <ac:chgData name="Tiago Beltrao Lacerda" userId="a6cfa6f6-6314-4baf-b142-94e6e4254abd" providerId="ADAL" clId="{397B3CA5-8420-4BB2-A10F-11EC221A7B9F}" dt="2025-05-31T21:35:17.918" v="55" actId="1076"/>
-          <ac:picMkLst>
-            <pc:docMk/>
-            <pc:sldMk cId="1106815609" sldId="257"/>
-            <ac:picMk id="10" creationId="{302CFB1B-3512-CB92-E279-E25370D5361A}"/>
-          </ac:picMkLst>
-        </pc:picChg>
-        <pc:picChg chg="del">
-          <ac:chgData name="Tiago Beltrao Lacerda" userId="a6cfa6f6-6314-4baf-b142-94e6e4254abd" providerId="ADAL" clId="{397B3CA5-8420-4BB2-A10F-11EC221A7B9F}" dt="2025-05-31T21:31:25.833" v="32" actId="478"/>
-          <ac:picMkLst>
-            <pc:docMk/>
-            <pc:sldMk cId="1106815609" sldId="257"/>
-            <ac:picMk id="11" creationId="{50BB68BC-9945-6454-9916-C12F87B5B2B5}"/>
-          </ac:picMkLst>
-        </pc:picChg>
-        <pc:picChg chg="add mod">
-          <ac:chgData name="Tiago Beltrao Lacerda" userId="a6cfa6f6-6314-4baf-b142-94e6e4254abd" providerId="ADAL" clId="{397B3CA5-8420-4BB2-A10F-11EC221A7B9F}" dt="2025-05-31T21:36:12.591" v="57" actId="1076"/>
-          <ac:picMkLst>
-            <pc:docMk/>
-            <pc:sldMk cId="1106815609" sldId="257"/>
-            <ac:picMk id="14" creationId="{7DB88346-94E0-88BC-9703-673E0852DCF4}"/>
-          </ac:picMkLst>
-        </pc:picChg>
-        <pc:picChg chg="add mod">
-          <ac:chgData name="Tiago Beltrao Lacerda" userId="a6cfa6f6-6314-4baf-b142-94e6e4254abd" providerId="ADAL" clId="{397B3CA5-8420-4BB2-A10F-11EC221A7B9F}" dt="2025-05-31T21:36:52.093" v="59" actId="1076"/>
-          <ac:picMkLst>
-            <pc:docMk/>
-            <pc:sldMk cId="1106815609" sldId="257"/>
-            <ac:picMk id="16" creationId="{417E65B1-7ACD-D64B-2864-CCAC7A9740D4}"/>
-          </ac:picMkLst>
-        </pc:picChg>
-        <pc:picChg chg="add mod">
-          <ac:chgData name="Tiago Beltrao Lacerda" userId="a6cfa6f6-6314-4baf-b142-94e6e4254abd" providerId="ADAL" clId="{397B3CA5-8420-4BB2-A10F-11EC221A7B9F}" dt="2025-05-31T21:37:09.435" v="61" actId="1076"/>
-          <ac:picMkLst>
-            <pc:docMk/>
-            <pc:sldMk cId="1106815609" sldId="257"/>
-            <ac:picMk id="18" creationId="{F793426D-D39B-1610-24B5-23BA28855EAD}"/>
-          </ac:picMkLst>
-        </pc:picChg>
       </pc:sldChg>
       <pc:sldChg chg="addSp delSp modSp add mod">
         <pc:chgData name="Tiago Beltrao Lacerda" userId="a6cfa6f6-6314-4baf-b142-94e6e4254abd" providerId="ADAL" clId="{397B3CA5-8420-4BB2-A10F-11EC221A7B9F}" dt="2025-06-01T15:53:32.078" v="149" actId="1076"/>
@@ -293,126 +288,6 @@
           <pc:docMk/>
           <pc:sldMk cId="3804799167" sldId="258"/>
         </pc:sldMkLst>
-        <pc:spChg chg="mod">
-          <ac:chgData name="Tiago Beltrao Lacerda" userId="a6cfa6f6-6314-4baf-b142-94e6e4254abd" providerId="ADAL" clId="{397B3CA5-8420-4BB2-A10F-11EC221A7B9F}" dt="2025-06-01T15:04:56.693" v="121" actId="20577"/>
-          <ac:spMkLst>
-            <pc:docMk/>
-            <pc:sldMk cId="3804799167" sldId="258"/>
-            <ac:spMk id="12" creationId="{0FC503EB-D55B-9CAB-BEA8-74846039F3EF}"/>
-          </ac:spMkLst>
-        </pc:spChg>
-        <pc:picChg chg="add del mod">
-          <ac:chgData name="Tiago Beltrao Lacerda" userId="a6cfa6f6-6314-4baf-b142-94e6e4254abd" providerId="ADAL" clId="{397B3CA5-8420-4BB2-A10F-11EC221A7B9F}" dt="2025-05-31T23:48:22.780" v="83" actId="478"/>
-          <ac:picMkLst>
-            <pc:docMk/>
-            <pc:sldMk cId="3804799167" sldId="258"/>
-            <ac:picMk id="3" creationId="{70A18872-777A-C685-8C1C-504D62D53FEB}"/>
-          </ac:picMkLst>
-        </pc:picChg>
-        <pc:picChg chg="add del mod">
-          <ac:chgData name="Tiago Beltrao Lacerda" userId="a6cfa6f6-6314-4baf-b142-94e6e4254abd" providerId="ADAL" clId="{397B3CA5-8420-4BB2-A10F-11EC221A7B9F}" dt="2025-05-31T23:07:10.232" v="80" actId="478"/>
-          <ac:picMkLst>
-            <pc:docMk/>
-            <pc:sldMk cId="3804799167" sldId="258"/>
-            <ac:picMk id="5" creationId="{E60F9514-CC5F-FE74-8FC9-948AA963D871}"/>
-          </ac:picMkLst>
-        </pc:picChg>
-        <pc:picChg chg="del">
-          <ac:chgData name="Tiago Beltrao Lacerda" userId="a6cfa6f6-6314-4baf-b142-94e6e4254abd" providerId="ADAL" clId="{397B3CA5-8420-4BB2-A10F-11EC221A7B9F}" dt="2025-05-31T21:39:05.328" v="63" actId="478"/>
-          <ac:picMkLst>
-            <pc:docMk/>
-            <pc:sldMk cId="3804799167" sldId="258"/>
-            <ac:picMk id="6" creationId="{5970900E-19CA-2092-23AC-9C8C6B71C750}"/>
-          </ac:picMkLst>
-        </pc:picChg>
-        <pc:picChg chg="add del mod">
-          <ac:chgData name="Tiago Beltrao Lacerda" userId="a6cfa6f6-6314-4baf-b142-94e6e4254abd" providerId="ADAL" clId="{397B3CA5-8420-4BB2-A10F-11EC221A7B9F}" dt="2025-05-31T23:07:05.446" v="77" actId="478"/>
-          <ac:picMkLst>
-            <pc:docMk/>
-            <pc:sldMk cId="3804799167" sldId="258"/>
-            <ac:picMk id="8" creationId="{803B2080-9B41-950D-6A7E-847BE121929A}"/>
-          </ac:picMkLst>
-        </pc:picChg>
-        <pc:picChg chg="del">
-          <ac:chgData name="Tiago Beltrao Lacerda" userId="a6cfa6f6-6314-4baf-b142-94e6e4254abd" providerId="ADAL" clId="{397B3CA5-8420-4BB2-A10F-11EC221A7B9F}" dt="2025-05-31T23:06:58.804" v="73" actId="478"/>
-          <ac:picMkLst>
-            <pc:docMk/>
-            <pc:sldMk cId="3804799167" sldId="258"/>
-            <ac:picMk id="10" creationId="{1CCF6BD7-A135-A842-B38B-D1428942C6F0}"/>
-          </ac:picMkLst>
-        </pc:picChg>
-        <pc:picChg chg="add mod">
-          <ac:chgData name="Tiago Beltrao Lacerda" userId="a6cfa6f6-6314-4baf-b142-94e6e4254abd" providerId="ADAL" clId="{397B3CA5-8420-4BB2-A10F-11EC221A7B9F}" dt="2025-05-31T23:48:26.285" v="85" actId="1076"/>
-          <ac:picMkLst>
-            <pc:docMk/>
-            <pc:sldMk cId="3804799167" sldId="258"/>
-            <ac:picMk id="11" creationId="{8441E7E8-03B1-3B40-CC71-EF5A0BA5D047}"/>
-          </ac:picMkLst>
-        </pc:picChg>
-        <pc:picChg chg="del">
-          <ac:chgData name="Tiago Beltrao Lacerda" userId="a6cfa6f6-6314-4baf-b142-94e6e4254abd" providerId="ADAL" clId="{397B3CA5-8420-4BB2-A10F-11EC221A7B9F}" dt="2025-05-31T23:07:07.463" v="78" actId="478"/>
-          <ac:picMkLst>
-            <pc:docMk/>
-            <pc:sldMk cId="3804799167" sldId="258"/>
-            <ac:picMk id="14" creationId="{A43DE2C8-731D-7F11-8273-4C3EFC075142}"/>
-          </ac:picMkLst>
-        </pc:picChg>
-        <pc:picChg chg="add mod">
-          <ac:chgData name="Tiago Beltrao Lacerda" userId="a6cfa6f6-6314-4baf-b142-94e6e4254abd" providerId="ADAL" clId="{397B3CA5-8420-4BB2-A10F-11EC221A7B9F}" dt="2025-05-31T23:48:40.169" v="87" actId="1076"/>
-          <ac:picMkLst>
-            <pc:docMk/>
-            <pc:sldMk cId="3804799167" sldId="258"/>
-            <ac:picMk id="15" creationId="{2F1D7703-0204-CA53-FAD1-46AAE2FC4BF6}"/>
-          </ac:picMkLst>
-        </pc:picChg>
-        <pc:picChg chg="del">
-          <ac:chgData name="Tiago Beltrao Lacerda" userId="a6cfa6f6-6314-4baf-b142-94e6e4254abd" providerId="ADAL" clId="{397B3CA5-8420-4BB2-A10F-11EC221A7B9F}" dt="2025-05-31T23:07:09.185" v="79" actId="478"/>
-          <ac:picMkLst>
-            <pc:docMk/>
-            <pc:sldMk cId="3804799167" sldId="258"/>
-            <ac:picMk id="16" creationId="{7A1070BE-B295-D831-51E9-FBA13D8EC0AF}"/>
-          </ac:picMkLst>
-        </pc:picChg>
-        <pc:picChg chg="del mod">
-          <ac:chgData name="Tiago Beltrao Lacerda" userId="a6cfa6f6-6314-4baf-b142-94e6e4254abd" providerId="ADAL" clId="{397B3CA5-8420-4BB2-A10F-11EC221A7B9F}" dt="2025-05-31T23:02:16.698" v="69" actId="478"/>
-          <ac:picMkLst>
-            <pc:docMk/>
-            <pc:sldMk cId="3804799167" sldId="258"/>
-            <ac:picMk id="18" creationId="{312FDEB7-5360-0786-DE69-61A50705C6CB}"/>
-          </ac:picMkLst>
-        </pc:picChg>
-        <pc:picChg chg="add mod">
-          <ac:chgData name="Tiago Beltrao Lacerda" userId="a6cfa6f6-6314-4baf-b142-94e6e4254abd" providerId="ADAL" clId="{397B3CA5-8420-4BB2-A10F-11EC221A7B9F}" dt="2025-05-31T23:49:02.233" v="89" actId="1076"/>
-          <ac:picMkLst>
-            <pc:docMk/>
-            <pc:sldMk cId="3804799167" sldId="258"/>
-            <ac:picMk id="19" creationId="{63573ABC-C8AE-E46B-3FE0-824E62C5FDD3}"/>
-          </ac:picMkLst>
-        </pc:picChg>
-        <pc:picChg chg="add mod">
-          <ac:chgData name="Tiago Beltrao Lacerda" userId="a6cfa6f6-6314-4baf-b142-94e6e4254abd" providerId="ADAL" clId="{397B3CA5-8420-4BB2-A10F-11EC221A7B9F}" dt="2025-05-31T23:49:15.768" v="91" actId="1076"/>
-          <ac:picMkLst>
-            <pc:docMk/>
-            <pc:sldMk cId="3804799167" sldId="258"/>
-            <ac:picMk id="21" creationId="{47402DCD-C0A4-AD31-8A0F-C37D622B3B04}"/>
-          </ac:picMkLst>
-        </pc:picChg>
-        <pc:picChg chg="add mod">
-          <ac:chgData name="Tiago Beltrao Lacerda" userId="a6cfa6f6-6314-4baf-b142-94e6e4254abd" providerId="ADAL" clId="{397B3CA5-8420-4BB2-A10F-11EC221A7B9F}" dt="2025-05-31T23:49:28.858" v="93" actId="1076"/>
-          <ac:picMkLst>
-            <pc:docMk/>
-            <pc:sldMk cId="3804799167" sldId="258"/>
-            <ac:picMk id="23" creationId="{AC62BCD4-B956-EB24-EE17-0E25E3C48454}"/>
-          </ac:picMkLst>
-        </pc:picChg>
-        <pc:picChg chg="add mod">
-          <ac:chgData name="Tiago Beltrao Lacerda" userId="a6cfa6f6-6314-4baf-b142-94e6e4254abd" providerId="ADAL" clId="{397B3CA5-8420-4BB2-A10F-11EC221A7B9F}" dt="2025-06-01T15:53:32.078" v="149" actId="1076"/>
-          <ac:picMkLst>
-            <pc:docMk/>
-            <pc:sldMk cId="3804799167" sldId="258"/>
-            <ac:picMk id="25" creationId="{27D6AB22-948A-88CC-8412-5CC0F86C4E4A}"/>
-          </ac:picMkLst>
-        </pc:picChg>
       </pc:sldChg>
       <pc:sldChg chg="addSp delSp modSp add mod">
         <pc:chgData name="Tiago Beltrao Lacerda" userId="a6cfa6f6-6314-4baf-b142-94e6e4254abd" providerId="ADAL" clId="{397B3CA5-8420-4BB2-A10F-11EC221A7B9F}" dt="2025-06-01T15:53:15.877" v="147" actId="1076"/>
@@ -420,94 +295,6 @@
           <pc:docMk/>
           <pc:sldMk cId="855907889" sldId="259"/>
         </pc:sldMkLst>
-        <pc:spChg chg="mod">
-          <ac:chgData name="Tiago Beltrao Lacerda" userId="a6cfa6f6-6314-4baf-b142-94e6e4254abd" providerId="ADAL" clId="{397B3CA5-8420-4BB2-A10F-11EC221A7B9F}" dt="2025-06-01T15:05:05.219" v="128" actId="20577"/>
-          <ac:spMkLst>
-            <pc:docMk/>
-            <pc:sldMk cId="855907889" sldId="259"/>
-            <ac:spMk id="12" creationId="{EBC662AA-EA11-41F8-569C-95F4AC3D2E38}"/>
-          </ac:spMkLst>
-        </pc:spChg>
-        <pc:picChg chg="add del mod">
-          <ac:chgData name="Tiago Beltrao Lacerda" userId="a6cfa6f6-6314-4baf-b142-94e6e4254abd" providerId="ADAL" clId="{397B3CA5-8420-4BB2-A10F-11EC221A7B9F}" dt="2025-06-01T15:52:50.472" v="141" actId="478"/>
-          <ac:picMkLst>
-            <pc:docMk/>
-            <pc:sldMk cId="855907889" sldId="259"/>
-            <ac:picMk id="3" creationId="{7F14E6B1-9630-2888-DDC8-C818B795D27F}"/>
-          </ac:picMkLst>
-        </pc:picChg>
-        <pc:picChg chg="add mod">
-          <ac:chgData name="Tiago Beltrao Lacerda" userId="a6cfa6f6-6314-4baf-b142-94e6e4254abd" providerId="ADAL" clId="{397B3CA5-8420-4BB2-A10F-11EC221A7B9F}" dt="2025-06-01T15:52:06.652" v="137" actId="1076"/>
-          <ac:picMkLst>
-            <pc:docMk/>
-            <pc:sldMk cId="855907889" sldId="259"/>
-            <ac:picMk id="5" creationId="{B60547CC-428E-6FA0-1014-77EF76AC9510}"/>
-          </ac:picMkLst>
-        </pc:picChg>
-        <pc:picChg chg="add mod">
-          <ac:chgData name="Tiago Beltrao Lacerda" userId="a6cfa6f6-6314-4baf-b142-94e6e4254abd" providerId="ADAL" clId="{397B3CA5-8420-4BB2-A10F-11EC221A7B9F}" dt="2025-06-01T15:52:30.650" v="140" actId="1076"/>
-          <ac:picMkLst>
-            <pc:docMk/>
-            <pc:sldMk cId="855907889" sldId="259"/>
-            <ac:picMk id="7" creationId="{788645E8-3430-C9E4-99DF-DED45D910663}"/>
-          </ac:picMkLst>
-        </pc:picChg>
-        <pc:picChg chg="add mod">
-          <ac:chgData name="Tiago Beltrao Lacerda" userId="a6cfa6f6-6314-4baf-b142-94e6e4254abd" providerId="ADAL" clId="{397B3CA5-8420-4BB2-A10F-11EC221A7B9F}" dt="2025-06-01T15:52:57.582" v="145" actId="14100"/>
-          <ac:picMkLst>
-            <pc:docMk/>
-            <pc:sldMk cId="855907889" sldId="259"/>
-            <ac:picMk id="9" creationId="{E5A7528A-4D94-8349-29F0-D6D3E568871F}"/>
-          </ac:picMkLst>
-        </pc:picChg>
-        <pc:picChg chg="del">
-          <ac:chgData name="Tiago Beltrao Lacerda" userId="a6cfa6f6-6314-4baf-b142-94e6e4254abd" providerId="ADAL" clId="{397B3CA5-8420-4BB2-A10F-11EC221A7B9F}" dt="2025-06-01T15:05:02.941" v="125" actId="478"/>
-          <ac:picMkLst>
-            <pc:docMk/>
-            <pc:sldMk cId="855907889" sldId="259"/>
-            <ac:picMk id="11" creationId="{58C68E04-ED82-A78A-099D-0D716EBDF65F}"/>
-          </ac:picMkLst>
-        </pc:picChg>
-        <pc:picChg chg="add mod">
-          <ac:chgData name="Tiago Beltrao Lacerda" userId="a6cfa6f6-6314-4baf-b142-94e6e4254abd" providerId="ADAL" clId="{397B3CA5-8420-4BB2-A10F-11EC221A7B9F}" dt="2025-06-01T15:53:15.877" v="147" actId="1076"/>
-          <ac:picMkLst>
-            <pc:docMk/>
-            <pc:sldMk cId="855907889" sldId="259"/>
-            <ac:picMk id="13" creationId="{2987115C-D42E-1A76-F416-3675F6182702}"/>
-          </ac:picMkLst>
-        </pc:picChg>
-        <pc:picChg chg="del">
-          <ac:chgData name="Tiago Beltrao Lacerda" userId="a6cfa6f6-6314-4baf-b142-94e6e4254abd" providerId="ADAL" clId="{397B3CA5-8420-4BB2-A10F-11EC221A7B9F}" dt="2025-06-01T15:05:00.377" v="123" actId="478"/>
-          <ac:picMkLst>
-            <pc:docMk/>
-            <pc:sldMk cId="855907889" sldId="259"/>
-            <ac:picMk id="15" creationId="{C8181759-9627-1840-F290-C0A9C8CACB92}"/>
-          </ac:picMkLst>
-        </pc:picChg>
-        <pc:picChg chg="del">
-          <ac:chgData name="Tiago Beltrao Lacerda" userId="a6cfa6f6-6314-4baf-b142-94e6e4254abd" providerId="ADAL" clId="{397B3CA5-8420-4BB2-A10F-11EC221A7B9F}" dt="2025-06-01T15:05:02.444" v="124" actId="478"/>
-          <ac:picMkLst>
-            <pc:docMk/>
-            <pc:sldMk cId="855907889" sldId="259"/>
-            <ac:picMk id="19" creationId="{60FE034D-810E-DC2E-5B28-3A219EE5941E}"/>
-          </ac:picMkLst>
-        </pc:picChg>
-        <pc:picChg chg="del">
-          <ac:chgData name="Tiago Beltrao Lacerda" userId="a6cfa6f6-6314-4baf-b142-94e6e4254abd" providerId="ADAL" clId="{397B3CA5-8420-4BB2-A10F-11EC221A7B9F}" dt="2025-06-01T15:05:02.444" v="124" actId="478"/>
-          <ac:picMkLst>
-            <pc:docMk/>
-            <pc:sldMk cId="855907889" sldId="259"/>
-            <ac:picMk id="21" creationId="{2A90DBB8-A691-DF44-385A-A7D1FD852E6C}"/>
-          </ac:picMkLst>
-        </pc:picChg>
-        <pc:picChg chg="del">
-          <ac:chgData name="Tiago Beltrao Lacerda" userId="a6cfa6f6-6314-4baf-b142-94e6e4254abd" providerId="ADAL" clId="{397B3CA5-8420-4BB2-A10F-11EC221A7B9F}" dt="2025-06-01T15:05:02.444" v="124" actId="478"/>
-          <ac:picMkLst>
-            <pc:docMk/>
-            <pc:sldMk cId="855907889" sldId="259"/>
-            <ac:picMk id="23" creationId="{335A4E97-12A8-0532-F024-7E91F8F5640C}"/>
-          </ac:picMkLst>
-        </pc:picChg>
       </pc:sldChg>
       <pc:sldChg chg="addSp delSp modSp add mod">
         <pc:chgData name="Tiago Beltrao Lacerda" userId="a6cfa6f6-6314-4baf-b142-94e6e4254abd" providerId="ADAL" clId="{397B3CA5-8420-4BB2-A10F-11EC221A7B9F}" dt="2025-06-01T18:28:56.286" v="168" actId="1076"/>
@@ -515,86 +302,6 @@
           <pc:docMk/>
           <pc:sldMk cId="652017484" sldId="260"/>
         </pc:sldMkLst>
-        <pc:spChg chg="mod">
-          <ac:chgData name="Tiago Beltrao Lacerda" userId="a6cfa6f6-6314-4baf-b142-94e6e4254abd" providerId="ADAL" clId="{397B3CA5-8420-4BB2-A10F-11EC221A7B9F}" dt="2025-06-01T18:26:57.045" v="152" actId="20577"/>
-          <ac:spMkLst>
-            <pc:docMk/>
-            <pc:sldMk cId="652017484" sldId="260"/>
-            <ac:spMk id="12" creationId="{3720515B-F413-DDE4-B689-0399D1EB13D3}"/>
-          </ac:spMkLst>
-        </pc:spChg>
-        <pc:picChg chg="add mod">
-          <ac:chgData name="Tiago Beltrao Lacerda" userId="a6cfa6f6-6314-4baf-b142-94e6e4254abd" providerId="ADAL" clId="{397B3CA5-8420-4BB2-A10F-11EC221A7B9F}" dt="2025-06-01T18:28:26.863" v="164" actId="1076"/>
-          <ac:picMkLst>
-            <pc:docMk/>
-            <pc:sldMk cId="652017484" sldId="260"/>
-            <ac:picMk id="3" creationId="{ED13EBEE-931F-9D9F-D2D0-FB4ECD677EAF}"/>
-          </ac:picMkLst>
-        </pc:picChg>
-        <pc:picChg chg="del">
-          <ac:chgData name="Tiago Beltrao Lacerda" userId="a6cfa6f6-6314-4baf-b142-94e6e4254abd" providerId="ADAL" clId="{397B3CA5-8420-4BB2-A10F-11EC221A7B9F}" dt="2025-06-01T18:27:00.467" v="156" actId="478"/>
-          <ac:picMkLst>
-            <pc:docMk/>
-            <pc:sldMk cId="652017484" sldId="260"/>
-            <ac:picMk id="5" creationId="{BBBAA0A8-42EF-786D-AEE0-9BC91BFE5871}"/>
-          </ac:picMkLst>
-        </pc:picChg>
-        <pc:picChg chg="add mod">
-          <ac:chgData name="Tiago Beltrao Lacerda" userId="a6cfa6f6-6314-4baf-b142-94e6e4254abd" providerId="ADAL" clId="{397B3CA5-8420-4BB2-A10F-11EC221A7B9F}" dt="2025-06-01T18:27:16.227" v="160" actId="1076"/>
-          <ac:picMkLst>
-            <pc:docMk/>
-            <pc:sldMk cId="652017484" sldId="260"/>
-            <ac:picMk id="6" creationId="{F75F312B-4308-0B97-AD8A-A4C3165F2622}"/>
-          </ac:picMkLst>
-        </pc:picChg>
-        <pc:picChg chg="del">
-          <ac:chgData name="Tiago Beltrao Lacerda" userId="a6cfa6f6-6314-4baf-b142-94e6e4254abd" providerId="ADAL" clId="{397B3CA5-8420-4BB2-A10F-11EC221A7B9F}" dt="2025-06-01T18:26:59.670" v="155" actId="478"/>
-          <ac:picMkLst>
-            <pc:docMk/>
-            <pc:sldMk cId="652017484" sldId="260"/>
-            <ac:picMk id="7" creationId="{817B181D-1804-69DF-6B6A-288ACB0F24D3}"/>
-          </ac:picMkLst>
-        </pc:picChg>
-        <pc:picChg chg="del">
-          <ac:chgData name="Tiago Beltrao Lacerda" userId="a6cfa6f6-6314-4baf-b142-94e6e4254abd" providerId="ADAL" clId="{397B3CA5-8420-4BB2-A10F-11EC221A7B9F}" dt="2025-06-01T18:26:58.155" v="153" actId="478"/>
-          <ac:picMkLst>
-            <pc:docMk/>
-            <pc:sldMk cId="652017484" sldId="260"/>
-            <ac:picMk id="9" creationId="{A2AFF736-3DA0-E140-1CB7-6EDC55563013}"/>
-          </ac:picMkLst>
-        </pc:picChg>
-        <pc:picChg chg="add mod">
-          <ac:chgData name="Tiago Beltrao Lacerda" userId="a6cfa6f6-6314-4baf-b142-94e6e4254abd" providerId="ADAL" clId="{397B3CA5-8420-4BB2-A10F-11EC221A7B9F}" dt="2025-06-01T18:28:24.445" v="163" actId="1076"/>
-          <ac:picMkLst>
-            <pc:docMk/>
-            <pc:sldMk cId="652017484" sldId="260"/>
-            <ac:picMk id="10" creationId="{AF6C5A74-D7DF-D075-427A-7925DC0939E1}"/>
-          </ac:picMkLst>
-        </pc:picChg>
-        <pc:picChg chg="del">
-          <ac:chgData name="Tiago Beltrao Lacerda" userId="a6cfa6f6-6314-4baf-b142-94e6e4254abd" providerId="ADAL" clId="{397B3CA5-8420-4BB2-A10F-11EC221A7B9F}" dt="2025-06-01T18:26:59.261" v="154" actId="478"/>
-          <ac:picMkLst>
-            <pc:docMk/>
-            <pc:sldMk cId="652017484" sldId="260"/>
-            <ac:picMk id="13" creationId="{C0C52E21-7F8D-7C2C-C789-1073FD5886F1}"/>
-          </ac:picMkLst>
-        </pc:picChg>
-        <pc:picChg chg="add mod">
-          <ac:chgData name="Tiago Beltrao Lacerda" userId="a6cfa6f6-6314-4baf-b142-94e6e4254abd" providerId="ADAL" clId="{397B3CA5-8420-4BB2-A10F-11EC221A7B9F}" dt="2025-06-01T18:28:43.933" v="166" actId="1076"/>
-          <ac:picMkLst>
-            <pc:docMk/>
-            <pc:sldMk cId="652017484" sldId="260"/>
-            <ac:picMk id="14" creationId="{E21FA143-1C33-5D20-B284-29A4BA5B8A43}"/>
-          </ac:picMkLst>
-        </pc:picChg>
-        <pc:picChg chg="add mod">
-          <ac:chgData name="Tiago Beltrao Lacerda" userId="a6cfa6f6-6314-4baf-b142-94e6e4254abd" providerId="ADAL" clId="{397B3CA5-8420-4BB2-A10F-11EC221A7B9F}" dt="2025-06-01T18:28:56.286" v="168" actId="1076"/>
-          <ac:picMkLst>
-            <pc:docMk/>
-            <pc:sldMk cId="652017484" sldId="260"/>
-            <ac:picMk id="16" creationId="{858EC349-03DA-F268-DB17-7602FFCEF128}"/>
-          </ac:picMkLst>
-        </pc:picChg>
       </pc:sldChg>
       <pc:sldChg chg="addSp delSp modSp add mod">
         <pc:chgData name="Tiago Beltrao Lacerda" userId="a6cfa6f6-6314-4baf-b142-94e6e4254abd" providerId="ADAL" clId="{397B3CA5-8420-4BB2-A10F-11EC221A7B9F}" dt="2025-06-01T22:01:08.087" v="188" actId="1076"/>
@@ -602,94 +309,6 @@
           <pc:docMk/>
           <pc:sldMk cId="2899868402" sldId="261"/>
         </pc:sldMkLst>
-        <pc:spChg chg="mod">
-          <ac:chgData name="Tiago Beltrao Lacerda" userId="a6cfa6f6-6314-4baf-b142-94e6e4254abd" providerId="ADAL" clId="{397B3CA5-8420-4BB2-A10F-11EC221A7B9F}" dt="2025-06-01T21:59:36.475" v="171" actId="20577"/>
-          <ac:spMkLst>
-            <pc:docMk/>
-            <pc:sldMk cId="2899868402" sldId="261"/>
-            <ac:spMk id="12" creationId="{00D8BAD3-2FB9-3AB5-D8E0-C92888E9CADE}"/>
-          </ac:spMkLst>
-        </pc:spChg>
-        <pc:picChg chg="del">
-          <ac:chgData name="Tiago Beltrao Lacerda" userId="a6cfa6f6-6314-4baf-b142-94e6e4254abd" providerId="ADAL" clId="{397B3CA5-8420-4BB2-A10F-11EC221A7B9F}" dt="2025-06-01T22:00:13.733" v="179" actId="478"/>
-          <ac:picMkLst>
-            <pc:docMk/>
-            <pc:sldMk cId="2899868402" sldId="261"/>
-            <ac:picMk id="3" creationId="{51EED15B-D0E8-08E4-C96A-02B4154F90EF}"/>
-          </ac:picMkLst>
-        </pc:picChg>
-        <pc:picChg chg="add mod">
-          <ac:chgData name="Tiago Beltrao Lacerda" userId="a6cfa6f6-6314-4baf-b142-94e6e4254abd" providerId="ADAL" clId="{397B3CA5-8420-4BB2-A10F-11EC221A7B9F}" dt="2025-06-01T21:59:54.300" v="174" actId="1076"/>
-          <ac:picMkLst>
-            <pc:docMk/>
-            <pc:sldMk cId="2899868402" sldId="261"/>
-            <ac:picMk id="4" creationId="{2B44CFB2-13EE-23F3-1C59-581FFE62E465}"/>
-          </ac:picMkLst>
-        </pc:picChg>
-        <pc:picChg chg="del">
-          <ac:chgData name="Tiago Beltrao Lacerda" userId="a6cfa6f6-6314-4baf-b142-94e6e4254abd" providerId="ADAL" clId="{397B3CA5-8420-4BB2-A10F-11EC221A7B9F}" dt="2025-06-01T21:59:37.981" v="172" actId="478"/>
-          <ac:picMkLst>
-            <pc:docMk/>
-            <pc:sldMk cId="2899868402" sldId="261"/>
-            <ac:picMk id="6" creationId="{21BE64C8-F8FA-68E4-5AE4-D90B075B2A6D}"/>
-          </ac:picMkLst>
-        </pc:picChg>
-        <pc:picChg chg="add mod">
-          <ac:chgData name="Tiago Beltrao Lacerda" userId="a6cfa6f6-6314-4baf-b142-94e6e4254abd" providerId="ADAL" clId="{397B3CA5-8420-4BB2-A10F-11EC221A7B9F}" dt="2025-06-01T22:00:12.239" v="178" actId="1076"/>
-          <ac:picMkLst>
-            <pc:docMk/>
-            <pc:sldMk cId="2899868402" sldId="261"/>
-            <ac:picMk id="7" creationId="{D099B755-B7A0-0791-73C7-03ACC1136CA7}"/>
-          </ac:picMkLst>
-        </pc:picChg>
-        <pc:picChg chg="add mod">
-          <ac:chgData name="Tiago Beltrao Lacerda" userId="a6cfa6f6-6314-4baf-b142-94e6e4254abd" providerId="ADAL" clId="{397B3CA5-8420-4BB2-A10F-11EC221A7B9F}" dt="2025-06-01T22:00:27.641" v="181" actId="1076"/>
-          <ac:picMkLst>
-            <pc:docMk/>
-            <pc:sldMk cId="2899868402" sldId="261"/>
-            <ac:picMk id="9" creationId="{5B7FE01D-CD13-A1D6-3759-40CE8A5A36FA}"/>
-          </ac:picMkLst>
-        </pc:picChg>
-        <pc:picChg chg="del">
-          <ac:chgData name="Tiago Beltrao Lacerda" userId="a6cfa6f6-6314-4baf-b142-94e6e4254abd" providerId="ADAL" clId="{397B3CA5-8420-4BB2-A10F-11EC221A7B9F}" dt="2025-06-01T21:59:55.155" v="175" actId="478"/>
-          <ac:picMkLst>
-            <pc:docMk/>
-            <pc:sldMk cId="2899868402" sldId="261"/>
-            <ac:picMk id="10" creationId="{31A99684-8EB9-D93F-2084-434CD46C9B2C}"/>
-          </ac:picMkLst>
-        </pc:picChg>
-        <pc:picChg chg="add mod">
-          <ac:chgData name="Tiago Beltrao Lacerda" userId="a6cfa6f6-6314-4baf-b142-94e6e4254abd" providerId="ADAL" clId="{397B3CA5-8420-4BB2-A10F-11EC221A7B9F}" dt="2025-06-01T22:00:47.187" v="185" actId="1076"/>
-          <ac:picMkLst>
-            <pc:docMk/>
-            <pc:sldMk cId="2899868402" sldId="261"/>
-            <ac:picMk id="13" creationId="{75C77D93-4C28-1087-2101-FC61DB3FEBDD}"/>
-          </ac:picMkLst>
-        </pc:picChg>
-        <pc:picChg chg="del">
-          <ac:chgData name="Tiago Beltrao Lacerda" userId="a6cfa6f6-6314-4baf-b142-94e6e4254abd" providerId="ADAL" clId="{397B3CA5-8420-4BB2-A10F-11EC221A7B9F}" dt="2025-06-01T22:00:28.912" v="182" actId="478"/>
-          <ac:picMkLst>
-            <pc:docMk/>
-            <pc:sldMk cId="2899868402" sldId="261"/>
-            <ac:picMk id="14" creationId="{02439D31-A91E-FF75-B3C1-925069A93C52}"/>
-          </ac:picMkLst>
-        </pc:picChg>
-        <pc:picChg chg="del">
-          <ac:chgData name="Tiago Beltrao Lacerda" userId="a6cfa6f6-6314-4baf-b142-94e6e4254abd" providerId="ADAL" clId="{397B3CA5-8420-4BB2-A10F-11EC221A7B9F}" dt="2025-06-01T22:00:48.363" v="186" actId="478"/>
-          <ac:picMkLst>
-            <pc:docMk/>
-            <pc:sldMk cId="2899868402" sldId="261"/>
-            <ac:picMk id="16" creationId="{AD7860A4-4178-6285-F01A-EE53221760D4}"/>
-          </ac:picMkLst>
-        </pc:picChg>
-        <pc:picChg chg="add mod">
-          <ac:chgData name="Tiago Beltrao Lacerda" userId="a6cfa6f6-6314-4baf-b142-94e6e4254abd" providerId="ADAL" clId="{397B3CA5-8420-4BB2-A10F-11EC221A7B9F}" dt="2025-06-01T22:01:08.087" v="188" actId="1076"/>
-          <ac:picMkLst>
-            <pc:docMk/>
-            <pc:sldMk cId="2899868402" sldId="261"/>
-            <ac:picMk id="17" creationId="{57CF04C9-8613-3E87-2D8B-0B7AEDDBE112}"/>
-          </ac:picMkLst>
-        </pc:picChg>
       </pc:sldChg>
     </pc:docChg>
   </pc:docChgLst>
@@ -845,7 +464,7 @@
           <a:p>
             <a:fld id="{F8ABC733-B9F5-4D04-B1D1-E227F34B5E32}" type="datetimeFigureOut">
               <a:rPr lang="pt-BR" smtClean="0"/>
-              <a:t>31/05/2025</a:t>
+              <a:t>27/06/2025</a:t>
             </a:fld>
             <a:endParaRPr lang="pt-BR"/>
           </a:p>
@@ -1045,7 +664,7 @@
           <a:p>
             <a:fld id="{F8ABC733-B9F5-4D04-B1D1-E227F34B5E32}" type="datetimeFigureOut">
               <a:rPr lang="pt-BR" smtClean="0"/>
-              <a:t>31/05/2025</a:t>
+              <a:t>27/06/2025</a:t>
             </a:fld>
             <a:endParaRPr lang="pt-BR"/>
           </a:p>
@@ -1255,7 +874,7 @@
           <a:p>
             <a:fld id="{F8ABC733-B9F5-4D04-B1D1-E227F34B5E32}" type="datetimeFigureOut">
               <a:rPr lang="pt-BR" smtClean="0"/>
-              <a:t>31/05/2025</a:t>
+              <a:t>27/06/2025</a:t>
             </a:fld>
             <a:endParaRPr lang="pt-BR"/>
           </a:p>
@@ -1455,7 +1074,7 @@
           <a:p>
             <a:fld id="{F8ABC733-B9F5-4D04-B1D1-E227F34B5E32}" type="datetimeFigureOut">
               <a:rPr lang="pt-BR" smtClean="0"/>
-              <a:t>31/05/2025</a:t>
+              <a:t>27/06/2025</a:t>
             </a:fld>
             <a:endParaRPr lang="pt-BR"/>
           </a:p>
@@ -1731,7 +1350,7 @@
           <a:p>
             <a:fld id="{F8ABC733-B9F5-4D04-B1D1-E227F34B5E32}" type="datetimeFigureOut">
               <a:rPr lang="pt-BR" smtClean="0"/>
-              <a:t>31/05/2025</a:t>
+              <a:t>27/06/2025</a:t>
             </a:fld>
             <a:endParaRPr lang="pt-BR"/>
           </a:p>
@@ -1999,7 +1618,7 @@
           <a:p>
             <a:fld id="{F8ABC733-B9F5-4D04-B1D1-E227F34B5E32}" type="datetimeFigureOut">
               <a:rPr lang="pt-BR" smtClean="0"/>
-              <a:t>31/05/2025</a:t>
+              <a:t>27/06/2025</a:t>
             </a:fld>
             <a:endParaRPr lang="pt-BR"/>
           </a:p>
@@ -2414,7 +2033,7 @@
           <a:p>
             <a:fld id="{F8ABC733-B9F5-4D04-B1D1-E227F34B5E32}" type="datetimeFigureOut">
               <a:rPr lang="pt-BR" smtClean="0"/>
-              <a:t>31/05/2025</a:t>
+              <a:t>27/06/2025</a:t>
             </a:fld>
             <a:endParaRPr lang="pt-BR"/>
           </a:p>
@@ -2556,7 +2175,7 @@
           <a:p>
             <a:fld id="{F8ABC733-B9F5-4D04-B1D1-E227F34B5E32}" type="datetimeFigureOut">
               <a:rPr lang="pt-BR" smtClean="0"/>
-              <a:t>31/05/2025</a:t>
+              <a:t>27/06/2025</a:t>
             </a:fld>
             <a:endParaRPr lang="pt-BR"/>
           </a:p>
@@ -2669,7 +2288,7 @@
           <a:p>
             <a:fld id="{F8ABC733-B9F5-4D04-B1D1-E227F34B5E32}" type="datetimeFigureOut">
               <a:rPr lang="pt-BR" smtClean="0"/>
-              <a:t>31/05/2025</a:t>
+              <a:t>27/06/2025</a:t>
             </a:fld>
             <a:endParaRPr lang="pt-BR"/>
           </a:p>
@@ -2982,7 +2601,7 @@
           <a:p>
             <a:fld id="{F8ABC733-B9F5-4D04-B1D1-E227F34B5E32}" type="datetimeFigureOut">
               <a:rPr lang="pt-BR" smtClean="0"/>
-              <a:t>31/05/2025</a:t>
+              <a:t>27/06/2025</a:t>
             </a:fld>
             <a:endParaRPr lang="pt-BR"/>
           </a:p>
@@ -3271,7 +2890,7 @@
           <a:p>
             <a:fld id="{F8ABC733-B9F5-4D04-B1D1-E227F34B5E32}" type="datetimeFigureOut">
               <a:rPr lang="pt-BR" smtClean="0"/>
-              <a:t>31/05/2025</a:t>
+              <a:t>27/06/2025</a:t>
             </a:fld>
             <a:endParaRPr lang="pt-BR"/>
           </a:p>
@@ -3514,7 +3133,7 @@
           <a:p>
             <a:fld id="{F8ABC733-B9F5-4D04-B1D1-E227F34B5E32}" type="datetimeFigureOut">
               <a:rPr lang="pt-BR" smtClean="0"/>
-              <a:t>31/05/2025</a:t>
+              <a:t>27/06/2025</a:t>
             </a:fld>
             <a:endParaRPr lang="pt-BR"/>
           </a:p>
@@ -3980,126 +3599,6 @@
           <a:chExt cx="0" cy="0"/>
         </a:xfrm>
       </p:grpSpPr>
-      <p:pic>
-        <p:nvPicPr>
-          <p:cNvPr id="5" name="Picture 4">
-            <a:extLst>
-              <a:ext uri="{FF2B5EF4-FFF2-40B4-BE49-F238E27FC236}">
-                <a16:creationId xmlns:a16="http://schemas.microsoft.com/office/drawing/2014/main" id="{4A606BF5-CEA1-76AC-E0E8-0B1C3179FAC9}"/>
-              </a:ext>
-            </a:extLst>
-          </p:cNvPr>
-          <p:cNvPicPr>
-            <a:picLocks noChangeAspect="1"/>
-          </p:cNvPicPr>
-          <p:nvPr/>
-        </p:nvPicPr>
-        <p:blipFill>
-          <a:blip r:embed="rId2"/>
-          <a:stretch>
-            <a:fillRect/>
-          </a:stretch>
-        </p:blipFill>
-        <p:spPr>
-          <a:xfrm>
-            <a:off x="5846688" y="4420552"/>
-            <a:ext cx="4343400" cy="2381250"/>
-          </a:xfrm>
-          <a:prstGeom prst="rect">
-            <a:avLst/>
-          </a:prstGeom>
-        </p:spPr>
-      </p:pic>
-      <p:pic>
-        <p:nvPicPr>
-          <p:cNvPr id="7" name="Picture 6">
-            <a:extLst>
-              <a:ext uri="{FF2B5EF4-FFF2-40B4-BE49-F238E27FC236}">
-                <a16:creationId xmlns:a16="http://schemas.microsoft.com/office/drawing/2014/main" id="{222C6AEA-2F4C-ACF5-49DF-7544004C037C}"/>
-              </a:ext>
-            </a:extLst>
-          </p:cNvPr>
-          <p:cNvPicPr>
-            <a:picLocks noChangeAspect="1"/>
-          </p:cNvPicPr>
-          <p:nvPr/>
-        </p:nvPicPr>
-        <p:blipFill>
-          <a:blip r:embed="rId3"/>
-          <a:stretch>
-            <a:fillRect/>
-          </a:stretch>
-        </p:blipFill>
-        <p:spPr>
-          <a:xfrm>
-            <a:off x="10190088" y="4420552"/>
-            <a:ext cx="1771650" cy="781050"/>
-          </a:xfrm>
-          <a:prstGeom prst="rect">
-            <a:avLst/>
-          </a:prstGeom>
-        </p:spPr>
-      </p:pic>
-      <p:pic>
-        <p:nvPicPr>
-          <p:cNvPr id="9" name="Picture 8">
-            <a:extLst>
-              <a:ext uri="{FF2B5EF4-FFF2-40B4-BE49-F238E27FC236}">
-                <a16:creationId xmlns:a16="http://schemas.microsoft.com/office/drawing/2014/main" id="{EA0ED04D-C8EF-2F4A-D590-4F5C63283895}"/>
-              </a:ext>
-            </a:extLst>
-          </p:cNvPr>
-          <p:cNvPicPr>
-            <a:picLocks noChangeAspect="1"/>
-          </p:cNvPicPr>
-          <p:nvPr/>
-        </p:nvPicPr>
-        <p:blipFill>
-          <a:blip r:embed="rId4"/>
-          <a:stretch>
-            <a:fillRect/>
-          </a:stretch>
-        </p:blipFill>
-        <p:spPr>
-          <a:xfrm>
-            <a:off x="8148480" y="-122873"/>
-            <a:ext cx="4314825" cy="4543425"/>
-          </a:xfrm>
-          <a:prstGeom prst="rect">
-            <a:avLst/>
-          </a:prstGeom>
-        </p:spPr>
-      </p:pic>
-      <p:pic>
-        <p:nvPicPr>
-          <p:cNvPr id="11" name="Picture 10">
-            <a:extLst>
-              <a:ext uri="{FF2B5EF4-FFF2-40B4-BE49-F238E27FC236}">
-                <a16:creationId xmlns:a16="http://schemas.microsoft.com/office/drawing/2014/main" id="{1614B37E-9D45-5B6F-7405-1254833078E3}"/>
-              </a:ext>
-            </a:extLst>
-          </p:cNvPr>
-          <p:cNvPicPr>
-            <a:picLocks noChangeAspect="1"/>
-          </p:cNvPicPr>
-          <p:nvPr/>
-        </p:nvPicPr>
-        <p:blipFill>
-          <a:blip r:embed="rId5"/>
-          <a:stretch>
-            <a:fillRect/>
-          </a:stretch>
-        </p:blipFill>
-        <p:spPr>
-          <a:xfrm>
-            <a:off x="1814355" y="724852"/>
-            <a:ext cx="4162425" cy="6076950"/>
-          </a:xfrm>
-          <a:prstGeom prst="rect">
-            <a:avLst/>
-          </a:prstGeom>
-        </p:spPr>
-      </p:pic>
       <p:sp>
         <p:nvSpPr>
           <p:cNvPr id="12" name="TextBox 11">
@@ -4115,7 +3614,7 @@
         <p:spPr>
           <a:xfrm>
             <a:off x="2281187" y="336884"/>
-            <a:ext cx="998543" cy="369332"/>
+            <a:ext cx="3224088" cy="369332"/>
           </a:xfrm>
           <a:prstGeom prst="rect">
             <a:avLst/>
@@ -4134,11 +3633,1280 @@
                   <a:srgbClr val="0070C0"/>
                 </a:solidFill>
               </a:rPr>
-              <a:t>Entrada</a:t>
-            </a:r>
-          </a:p>
-        </p:txBody>
-      </p:sp>
+              <a:t>Como modelar estes riscos ?</a:t>
+            </a:r>
+          </a:p>
+        </p:txBody>
+      </p:sp>
+      <p:graphicFrame>
+        <p:nvGraphicFramePr>
+          <p:cNvPr id="3" name="Table 2">
+            <a:extLst>
+              <a:ext uri="{FF2B5EF4-FFF2-40B4-BE49-F238E27FC236}">
+                <a16:creationId xmlns:a16="http://schemas.microsoft.com/office/drawing/2014/main" id="{FB427889-2CB8-1D9C-6062-EA109112BEDE}"/>
+              </a:ext>
+            </a:extLst>
+          </p:cNvPr>
+          <p:cNvGraphicFramePr>
+            <a:graphicFrameLocks noGrp="1"/>
+          </p:cNvGraphicFramePr>
+          <p:nvPr>
+            <p:extLst>
+              <p:ext uri="{D42A27DB-BD31-4B8C-83A1-F6EECF244321}">
+                <p14:modId xmlns:p14="http://schemas.microsoft.com/office/powerpoint/2010/main" val="2448270317"/>
+              </p:ext>
+            </p:extLst>
+          </p:nvPr>
+        </p:nvGraphicFramePr>
+        <p:xfrm>
+          <a:off x="2032000" y="1401818"/>
+          <a:ext cx="4064000" cy="1143000"/>
+        </p:xfrm>
+        <a:graphic>
+          <a:graphicData uri="http://schemas.openxmlformats.org/drawingml/2006/table">
+            <a:tbl>
+              <a:tblPr/>
+              <a:tblGrid>
+                <a:gridCol w="635000">
+                  <a:extLst>
+                    <a:ext uri="{9D8B030D-6E8A-4147-A177-3AD203B41FA5}">
+                      <a16:colId xmlns:a16="http://schemas.microsoft.com/office/drawing/2014/main" val="1022895103"/>
+                    </a:ext>
+                  </a:extLst>
+                </a:gridCol>
+                <a:gridCol w="762000">
+                  <a:extLst>
+                    <a:ext uri="{9D8B030D-6E8A-4147-A177-3AD203B41FA5}">
+                      <a16:colId xmlns:a16="http://schemas.microsoft.com/office/drawing/2014/main" val="3228626042"/>
+                    </a:ext>
+                  </a:extLst>
+                </a:gridCol>
+                <a:gridCol w="1117600">
+                  <a:extLst>
+                    <a:ext uri="{9D8B030D-6E8A-4147-A177-3AD203B41FA5}">
+                      <a16:colId xmlns:a16="http://schemas.microsoft.com/office/drawing/2014/main" val="2563206494"/>
+                    </a:ext>
+                  </a:extLst>
+                </a:gridCol>
+                <a:gridCol w="850900">
+                  <a:extLst>
+                    <a:ext uri="{9D8B030D-6E8A-4147-A177-3AD203B41FA5}">
+                      <a16:colId xmlns:a16="http://schemas.microsoft.com/office/drawing/2014/main" val="708813748"/>
+                    </a:ext>
+                  </a:extLst>
+                </a:gridCol>
+                <a:gridCol w="698500">
+                  <a:extLst>
+                    <a:ext uri="{9D8B030D-6E8A-4147-A177-3AD203B41FA5}">
+                      <a16:colId xmlns:a16="http://schemas.microsoft.com/office/drawing/2014/main" val="2765070330"/>
+                    </a:ext>
+                  </a:extLst>
+                </a:gridCol>
+              </a:tblGrid>
+              <a:tr h="190500">
+                <a:tc>
+                  <a:txBody>
+                    <a:bodyPr/>
+                    <a:lstStyle/>
+                    <a:p>
+                      <a:pPr algn="ctr" fontAlgn="t"/>
+                      <a:r>
+                        <a:rPr lang="pt-BR" sz="1100" b="1" i="0" u="none" strike="noStrike">
+                          <a:solidFill>
+                            <a:srgbClr val="000000"/>
+                          </a:solidFill>
+                          <a:effectLst/>
+                          <a:latin typeface="Calibri" panose="020F0502020204030204" pitchFamily="34" charset="0"/>
+                        </a:rPr>
+                        <a:t>RISCO_TX</a:t>
+                      </a:r>
+                    </a:p>
+                  </a:txBody>
+                  <a:tcPr marL="9525" marR="9525" marT="9525" marB="0">
+                    <a:lnL w="6350" cap="flat" cmpd="sng" algn="ctr">
+                      <a:solidFill>
+                        <a:srgbClr val="000000"/>
+                      </a:solidFill>
+                      <a:prstDash val="solid"/>
+                      <a:round/>
+                      <a:headEnd type="none" w="med" len="med"/>
+                      <a:tailEnd type="none" w="med" len="med"/>
+                    </a:lnL>
+                    <a:lnR w="6350" cap="flat" cmpd="sng" algn="ctr">
+                      <a:solidFill>
+                        <a:srgbClr val="000000"/>
+                      </a:solidFill>
+                      <a:prstDash val="solid"/>
+                      <a:round/>
+                      <a:headEnd type="none" w="med" len="med"/>
+                      <a:tailEnd type="none" w="med" len="med"/>
+                    </a:lnR>
+                    <a:lnT w="6350" cap="flat" cmpd="sng" algn="ctr">
+                      <a:solidFill>
+                        <a:srgbClr val="000000"/>
+                      </a:solidFill>
+                      <a:prstDash val="solid"/>
+                      <a:round/>
+                      <a:headEnd type="none" w="med" len="med"/>
+                      <a:tailEnd type="none" w="med" len="med"/>
+                    </a:lnT>
+                    <a:lnB w="6350" cap="flat" cmpd="sng" algn="ctr">
+                      <a:solidFill>
+                        <a:srgbClr val="000000"/>
+                      </a:solidFill>
+                      <a:prstDash val="solid"/>
+                      <a:round/>
+                      <a:headEnd type="none" w="med" len="med"/>
+                      <a:tailEnd type="none" w="med" len="med"/>
+                    </a:lnB>
+                    <a:noFill/>
+                  </a:tcPr>
+                </a:tc>
+                <a:tc>
+                  <a:txBody>
+                    <a:bodyPr/>
+                    <a:lstStyle/>
+                    <a:p>
+                      <a:pPr algn="ctr" fontAlgn="t"/>
+                      <a:r>
+                        <a:rPr lang="pt-BR" sz="1100" b="1" i="0" u="none" strike="noStrike">
+                          <a:solidFill>
+                            <a:srgbClr val="000000"/>
+                          </a:solidFill>
+                          <a:effectLst/>
+                          <a:latin typeface="Calibri" panose="020F0502020204030204" pitchFamily="34" charset="0"/>
+                        </a:rPr>
+                        <a:t>RISCO_RFW</a:t>
+                      </a:r>
+                    </a:p>
+                  </a:txBody>
+                  <a:tcPr marL="9525" marR="9525" marT="9525" marB="0">
+                    <a:lnL w="6350" cap="flat" cmpd="sng" algn="ctr">
+                      <a:solidFill>
+                        <a:srgbClr val="000000"/>
+                      </a:solidFill>
+                      <a:prstDash val="solid"/>
+                      <a:round/>
+                      <a:headEnd type="none" w="med" len="med"/>
+                      <a:tailEnd type="none" w="med" len="med"/>
+                    </a:lnL>
+                    <a:lnR w="6350" cap="flat" cmpd="sng" algn="ctr">
+                      <a:solidFill>
+                        <a:srgbClr val="000000"/>
+                      </a:solidFill>
+                      <a:prstDash val="solid"/>
+                      <a:round/>
+                      <a:headEnd type="none" w="med" len="med"/>
+                      <a:tailEnd type="none" w="med" len="med"/>
+                    </a:lnR>
+                    <a:lnT w="6350" cap="flat" cmpd="sng" algn="ctr">
+                      <a:solidFill>
+                        <a:srgbClr val="000000"/>
+                      </a:solidFill>
+                      <a:prstDash val="solid"/>
+                      <a:round/>
+                      <a:headEnd type="none" w="med" len="med"/>
+                      <a:tailEnd type="none" w="med" len="med"/>
+                    </a:lnT>
+                    <a:lnB w="6350" cap="flat" cmpd="sng" algn="ctr">
+                      <a:solidFill>
+                        <a:srgbClr val="000000"/>
+                      </a:solidFill>
+                      <a:prstDash val="solid"/>
+                      <a:round/>
+                      <a:headEnd type="none" w="med" len="med"/>
+                      <a:tailEnd type="none" w="med" len="med"/>
+                    </a:lnB>
+                    <a:noFill/>
+                  </a:tcPr>
+                </a:tc>
+                <a:tc>
+                  <a:txBody>
+                    <a:bodyPr/>
+                    <a:lstStyle/>
+                    <a:p>
+                      <a:pPr algn="ctr" fontAlgn="t"/>
+                      <a:r>
+                        <a:rPr lang="pt-BR" sz="1100" b="1" i="0" u="none" strike="noStrike">
+                          <a:solidFill>
+                            <a:srgbClr val="000000"/>
+                          </a:solidFill>
+                          <a:effectLst/>
+                          <a:latin typeface="Calibri" panose="020F0502020204030204" pitchFamily="34" charset="0"/>
+                        </a:rPr>
+                        <a:t>RISCO_DETENTOR</a:t>
+                      </a:r>
+                    </a:p>
+                  </a:txBody>
+                  <a:tcPr marL="9525" marR="9525" marT="9525" marB="0">
+                    <a:lnL w="6350" cap="flat" cmpd="sng" algn="ctr">
+                      <a:solidFill>
+                        <a:srgbClr val="000000"/>
+                      </a:solidFill>
+                      <a:prstDash val="solid"/>
+                      <a:round/>
+                      <a:headEnd type="none" w="med" len="med"/>
+                      <a:tailEnd type="none" w="med" len="med"/>
+                    </a:lnL>
+                    <a:lnR w="6350" cap="flat" cmpd="sng" algn="ctr">
+                      <a:solidFill>
+                        <a:srgbClr val="000000"/>
+                      </a:solidFill>
+                      <a:prstDash val="solid"/>
+                      <a:round/>
+                      <a:headEnd type="none" w="med" len="med"/>
+                      <a:tailEnd type="none" w="med" len="med"/>
+                    </a:lnR>
+                    <a:lnT w="6350" cap="flat" cmpd="sng" algn="ctr">
+                      <a:solidFill>
+                        <a:srgbClr val="000000"/>
+                      </a:solidFill>
+                      <a:prstDash val="solid"/>
+                      <a:round/>
+                      <a:headEnd type="none" w="med" len="med"/>
+                      <a:tailEnd type="none" w="med" len="med"/>
+                    </a:lnT>
+                    <a:lnB w="6350" cap="flat" cmpd="sng" algn="ctr">
+                      <a:solidFill>
+                        <a:srgbClr val="000000"/>
+                      </a:solidFill>
+                      <a:prstDash val="solid"/>
+                      <a:round/>
+                      <a:headEnd type="none" w="med" len="med"/>
+                      <a:tailEnd type="none" w="med" len="med"/>
+                    </a:lnB>
+                    <a:noFill/>
+                  </a:tcPr>
+                </a:tc>
+                <a:tc>
+                  <a:txBody>
+                    <a:bodyPr/>
+                    <a:lstStyle/>
+                    <a:p>
+                      <a:pPr algn="ctr" fontAlgn="t"/>
+                      <a:r>
+                        <a:rPr lang="pt-BR" sz="1100" b="1" i="0" u="none" strike="noStrike">
+                          <a:solidFill>
+                            <a:srgbClr val="000000"/>
+                          </a:solidFill>
+                          <a:effectLst/>
+                          <a:latin typeface="Calibri" panose="020F0502020204030204" pitchFamily="34" charset="0"/>
+                        </a:rPr>
+                        <a:t>RISCO_INFRA</a:t>
+                      </a:r>
+                    </a:p>
+                  </a:txBody>
+                  <a:tcPr marL="9525" marR="9525" marT="9525" marB="0">
+                    <a:lnL w="6350" cap="flat" cmpd="sng" algn="ctr">
+                      <a:solidFill>
+                        <a:srgbClr val="000000"/>
+                      </a:solidFill>
+                      <a:prstDash val="solid"/>
+                      <a:round/>
+                      <a:headEnd type="none" w="med" len="med"/>
+                      <a:tailEnd type="none" w="med" len="med"/>
+                    </a:lnL>
+                    <a:lnR w="6350" cap="flat" cmpd="sng" algn="ctr">
+                      <a:solidFill>
+                        <a:srgbClr val="000000"/>
+                      </a:solidFill>
+                      <a:prstDash val="solid"/>
+                      <a:round/>
+                      <a:headEnd type="none" w="med" len="med"/>
+                      <a:tailEnd type="none" w="med" len="med"/>
+                    </a:lnR>
+                    <a:lnT w="6350" cap="flat" cmpd="sng" algn="ctr">
+                      <a:solidFill>
+                        <a:srgbClr val="000000"/>
+                      </a:solidFill>
+                      <a:prstDash val="solid"/>
+                      <a:round/>
+                      <a:headEnd type="none" w="med" len="med"/>
+                      <a:tailEnd type="none" w="med" len="med"/>
+                    </a:lnT>
+                    <a:lnB w="6350" cap="flat" cmpd="sng" algn="ctr">
+                      <a:solidFill>
+                        <a:srgbClr val="000000"/>
+                      </a:solidFill>
+                      <a:prstDash val="solid"/>
+                      <a:round/>
+                      <a:headEnd type="none" w="med" len="med"/>
+                      <a:tailEnd type="none" w="med" len="med"/>
+                    </a:lnB>
+                    <a:noFill/>
+                  </a:tcPr>
+                </a:tc>
+                <a:tc>
+                  <a:txBody>
+                    <a:bodyPr/>
+                    <a:lstStyle/>
+                    <a:p>
+                      <a:pPr algn="ctr" fontAlgn="t"/>
+                      <a:r>
+                        <a:rPr lang="pt-BR" sz="1100" b="1" i="0" u="none" strike="noStrike">
+                          <a:solidFill>
+                            <a:srgbClr val="000000"/>
+                          </a:solidFill>
+                          <a:effectLst/>
+                          <a:latin typeface="Calibri" panose="020F0502020204030204" pitchFamily="34" charset="0"/>
+                        </a:rPr>
+                        <a:t>URGENCIA</a:t>
+                      </a:r>
+                    </a:p>
+                  </a:txBody>
+                  <a:tcPr marL="9525" marR="9525" marT="9525" marB="0">
+                    <a:lnL w="6350" cap="flat" cmpd="sng" algn="ctr">
+                      <a:solidFill>
+                        <a:srgbClr val="000000"/>
+                      </a:solidFill>
+                      <a:prstDash val="solid"/>
+                      <a:round/>
+                      <a:headEnd type="none" w="med" len="med"/>
+                      <a:tailEnd type="none" w="med" len="med"/>
+                    </a:lnL>
+                    <a:lnR w="6350" cap="flat" cmpd="sng" algn="ctr">
+                      <a:solidFill>
+                        <a:srgbClr val="000000"/>
+                      </a:solidFill>
+                      <a:prstDash val="solid"/>
+                      <a:round/>
+                      <a:headEnd type="none" w="med" len="med"/>
+                      <a:tailEnd type="none" w="med" len="med"/>
+                    </a:lnR>
+                    <a:lnT w="6350" cap="flat" cmpd="sng" algn="ctr">
+                      <a:solidFill>
+                        <a:srgbClr val="000000"/>
+                      </a:solidFill>
+                      <a:prstDash val="solid"/>
+                      <a:round/>
+                      <a:headEnd type="none" w="med" len="med"/>
+                      <a:tailEnd type="none" w="med" len="med"/>
+                    </a:lnT>
+                    <a:lnB w="6350" cap="flat" cmpd="sng" algn="ctr">
+                      <a:solidFill>
+                        <a:srgbClr val="000000"/>
+                      </a:solidFill>
+                      <a:prstDash val="solid"/>
+                      <a:round/>
+                      <a:headEnd type="none" w="med" len="med"/>
+                      <a:tailEnd type="none" w="med" len="med"/>
+                    </a:lnB>
+                    <a:noFill/>
+                  </a:tcPr>
+                </a:tc>
+                <a:extLst>
+                  <a:ext uri="{0D108BD9-81ED-4DB2-BD59-A6C34878D82A}">
+                    <a16:rowId xmlns:a16="http://schemas.microsoft.com/office/drawing/2014/main" val="3275477322"/>
+                  </a:ext>
+                </a:extLst>
+              </a:tr>
+              <a:tr h="190500">
+                <a:tc>
+                  <a:txBody>
+                    <a:bodyPr/>
+                    <a:lstStyle/>
+                    <a:p>
+                      <a:pPr algn="r" fontAlgn="b"/>
+                      <a:r>
+                        <a:rPr lang="pt-BR" sz="1100" b="0" i="0" u="none" strike="noStrike">
+                          <a:solidFill>
+                            <a:srgbClr val="000000"/>
+                          </a:solidFill>
+                          <a:effectLst/>
+                          <a:latin typeface="Calibri" panose="020F0502020204030204" pitchFamily="34" charset="0"/>
+                        </a:rPr>
+                        <a:t>0,0509</a:t>
+                      </a:r>
+                    </a:p>
+                  </a:txBody>
+                  <a:tcPr marL="9525" marR="9525" marT="9525" marB="0" anchor="b">
+                    <a:lnL>
+                      <a:noFill/>
+                    </a:lnL>
+                    <a:lnR>
+                      <a:noFill/>
+                    </a:lnR>
+                    <a:lnT w="6350" cap="flat" cmpd="sng" algn="ctr">
+                      <a:solidFill>
+                        <a:srgbClr val="000000"/>
+                      </a:solidFill>
+                      <a:prstDash val="solid"/>
+                      <a:round/>
+                      <a:headEnd type="none" w="med" len="med"/>
+                      <a:tailEnd type="none" w="med" len="med"/>
+                    </a:lnT>
+                    <a:lnB>
+                      <a:noFill/>
+                    </a:lnB>
+                    <a:noFill/>
+                  </a:tcPr>
+                </a:tc>
+                <a:tc>
+                  <a:txBody>
+                    <a:bodyPr/>
+                    <a:lstStyle/>
+                    <a:p>
+                      <a:pPr algn="r" fontAlgn="b"/>
+                      <a:r>
+                        <a:rPr lang="pt-BR" sz="1100" b="0" i="0" u="none" strike="noStrike">
+                          <a:solidFill>
+                            <a:srgbClr val="000000"/>
+                          </a:solidFill>
+                          <a:effectLst/>
+                          <a:latin typeface="Calibri" panose="020F0502020204030204" pitchFamily="34" charset="0"/>
+                        </a:rPr>
+                        <a:t>0,0612</a:t>
+                      </a:r>
+                    </a:p>
+                  </a:txBody>
+                  <a:tcPr marL="9525" marR="9525" marT="9525" marB="0" anchor="b">
+                    <a:lnL>
+                      <a:noFill/>
+                    </a:lnL>
+                    <a:lnR>
+                      <a:noFill/>
+                    </a:lnR>
+                    <a:lnT w="6350" cap="flat" cmpd="sng" algn="ctr">
+                      <a:solidFill>
+                        <a:srgbClr val="000000"/>
+                      </a:solidFill>
+                      <a:prstDash val="solid"/>
+                      <a:round/>
+                      <a:headEnd type="none" w="med" len="med"/>
+                      <a:tailEnd type="none" w="med" len="med"/>
+                    </a:lnT>
+                    <a:lnB>
+                      <a:noFill/>
+                    </a:lnB>
+                    <a:noFill/>
+                  </a:tcPr>
+                </a:tc>
+                <a:tc>
+                  <a:txBody>
+                    <a:bodyPr/>
+                    <a:lstStyle/>
+                    <a:p>
+                      <a:pPr algn="r" fontAlgn="b"/>
+                      <a:r>
+                        <a:rPr lang="pt-BR" sz="1100" b="0" i="0" u="none" strike="noStrike">
+                          <a:solidFill>
+                            <a:srgbClr val="000000"/>
+                          </a:solidFill>
+                          <a:effectLst/>
+                          <a:latin typeface="Calibri" panose="020F0502020204030204" pitchFamily="34" charset="0"/>
+                        </a:rPr>
+                        <a:t>0,028</a:t>
+                      </a:r>
+                    </a:p>
+                  </a:txBody>
+                  <a:tcPr marL="9525" marR="9525" marT="9525" marB="0" anchor="b">
+                    <a:lnL>
+                      <a:noFill/>
+                    </a:lnL>
+                    <a:lnR>
+                      <a:noFill/>
+                    </a:lnR>
+                    <a:lnT w="6350" cap="flat" cmpd="sng" algn="ctr">
+                      <a:solidFill>
+                        <a:srgbClr val="000000"/>
+                      </a:solidFill>
+                      <a:prstDash val="solid"/>
+                      <a:round/>
+                      <a:headEnd type="none" w="med" len="med"/>
+                      <a:tailEnd type="none" w="med" len="med"/>
+                    </a:lnT>
+                    <a:lnB>
+                      <a:noFill/>
+                    </a:lnB>
+                    <a:noFill/>
+                  </a:tcPr>
+                </a:tc>
+                <a:tc>
+                  <a:txBody>
+                    <a:bodyPr/>
+                    <a:lstStyle/>
+                    <a:p>
+                      <a:pPr algn="r" fontAlgn="b"/>
+                      <a:r>
+                        <a:rPr lang="pt-BR" sz="1100" b="0" i="0" u="none" strike="noStrike">
+                          <a:solidFill>
+                            <a:srgbClr val="000000"/>
+                          </a:solidFill>
+                          <a:effectLst/>
+                          <a:latin typeface="Calibri" panose="020F0502020204030204" pitchFamily="34" charset="0"/>
+                        </a:rPr>
+                        <a:t>0,0239</a:t>
+                      </a:r>
+                    </a:p>
+                  </a:txBody>
+                  <a:tcPr marL="9525" marR="9525" marT="9525" marB="0" anchor="b">
+                    <a:lnL>
+                      <a:noFill/>
+                    </a:lnL>
+                    <a:lnR>
+                      <a:noFill/>
+                    </a:lnR>
+                    <a:lnT w="6350" cap="flat" cmpd="sng" algn="ctr">
+                      <a:solidFill>
+                        <a:srgbClr val="000000"/>
+                      </a:solidFill>
+                      <a:prstDash val="solid"/>
+                      <a:round/>
+                      <a:headEnd type="none" w="med" len="med"/>
+                      <a:tailEnd type="none" w="med" len="med"/>
+                    </a:lnT>
+                    <a:lnB>
+                      <a:noFill/>
+                    </a:lnB>
+                    <a:noFill/>
+                  </a:tcPr>
+                </a:tc>
+                <a:tc>
+                  <a:txBody>
+                    <a:bodyPr/>
+                    <a:lstStyle/>
+                    <a:p>
+                      <a:pPr algn="r" fontAlgn="b"/>
+                      <a:r>
+                        <a:rPr lang="pt-BR" sz="1100" b="0" i="0" u="none" strike="noStrike">
+                          <a:solidFill>
+                            <a:srgbClr val="000000"/>
+                          </a:solidFill>
+                          <a:effectLst/>
+                          <a:latin typeface="Calibri" panose="020F0502020204030204" pitchFamily="34" charset="0"/>
+                        </a:rPr>
+                        <a:t>0,1692</a:t>
+                      </a:r>
+                    </a:p>
+                  </a:txBody>
+                  <a:tcPr marL="9525" marR="9525" marT="9525" marB="0" anchor="b">
+                    <a:lnL>
+                      <a:noFill/>
+                    </a:lnL>
+                    <a:lnR>
+                      <a:noFill/>
+                    </a:lnR>
+                    <a:lnT w="6350" cap="flat" cmpd="sng" algn="ctr">
+                      <a:solidFill>
+                        <a:srgbClr val="000000"/>
+                      </a:solidFill>
+                      <a:prstDash val="solid"/>
+                      <a:round/>
+                      <a:headEnd type="none" w="med" len="med"/>
+                      <a:tailEnd type="none" w="med" len="med"/>
+                    </a:lnT>
+                    <a:lnB>
+                      <a:noFill/>
+                    </a:lnB>
+                    <a:noFill/>
+                  </a:tcPr>
+                </a:tc>
+                <a:extLst>
+                  <a:ext uri="{0D108BD9-81ED-4DB2-BD59-A6C34878D82A}">
+                    <a16:rowId xmlns:a16="http://schemas.microsoft.com/office/drawing/2014/main" val="3294599711"/>
+                  </a:ext>
+                </a:extLst>
+              </a:tr>
+              <a:tr h="190500">
+                <a:tc>
+                  <a:txBody>
+                    <a:bodyPr/>
+                    <a:lstStyle/>
+                    <a:p>
+                      <a:pPr algn="r" fontAlgn="b"/>
+                      <a:r>
+                        <a:rPr lang="pt-BR" sz="1100" b="0" i="0" u="none" strike="noStrike">
+                          <a:solidFill>
+                            <a:srgbClr val="000000"/>
+                          </a:solidFill>
+                          <a:effectLst/>
+                          <a:latin typeface="Calibri" panose="020F0502020204030204" pitchFamily="34" charset="0"/>
+                        </a:rPr>
+                        <a:t>-1</a:t>
+                      </a:r>
+                    </a:p>
+                  </a:txBody>
+                  <a:tcPr marL="9525" marR="9525" marT="9525" marB="0" anchor="b">
+                    <a:lnL>
+                      <a:noFill/>
+                    </a:lnL>
+                    <a:lnR>
+                      <a:noFill/>
+                    </a:lnR>
+                    <a:lnT>
+                      <a:noFill/>
+                    </a:lnT>
+                    <a:lnB>
+                      <a:noFill/>
+                    </a:lnB>
+                    <a:noFill/>
+                  </a:tcPr>
+                </a:tc>
+                <a:tc>
+                  <a:txBody>
+                    <a:bodyPr/>
+                    <a:lstStyle/>
+                    <a:p>
+                      <a:pPr algn="r" fontAlgn="b"/>
+                      <a:r>
+                        <a:rPr lang="pt-BR" sz="1100" b="0" i="0" u="none" strike="noStrike">
+                          <a:solidFill>
+                            <a:srgbClr val="000000"/>
+                          </a:solidFill>
+                          <a:effectLst/>
+                          <a:latin typeface="Calibri" panose="020F0502020204030204" pitchFamily="34" charset="0"/>
+                        </a:rPr>
+                        <a:t>1</a:t>
+                      </a:r>
+                    </a:p>
+                  </a:txBody>
+                  <a:tcPr marL="9525" marR="9525" marT="9525" marB="0" anchor="b">
+                    <a:lnL>
+                      <a:noFill/>
+                    </a:lnL>
+                    <a:lnR>
+                      <a:noFill/>
+                    </a:lnR>
+                    <a:lnT>
+                      <a:noFill/>
+                    </a:lnT>
+                    <a:lnB>
+                      <a:noFill/>
+                    </a:lnB>
+                    <a:noFill/>
+                  </a:tcPr>
+                </a:tc>
+                <a:tc>
+                  <a:txBody>
+                    <a:bodyPr/>
+                    <a:lstStyle/>
+                    <a:p>
+                      <a:pPr algn="r" fontAlgn="b"/>
+                      <a:r>
+                        <a:rPr lang="pt-BR" sz="1100" b="0" i="0" u="none" strike="noStrike">
+                          <a:solidFill>
+                            <a:srgbClr val="000000"/>
+                          </a:solidFill>
+                          <a:effectLst/>
+                          <a:latin typeface="Calibri" panose="020F0502020204030204" pitchFamily="34" charset="0"/>
+                        </a:rPr>
+                        <a:t>-1</a:t>
+                      </a:r>
+                    </a:p>
+                  </a:txBody>
+                  <a:tcPr marL="9525" marR="9525" marT="9525" marB="0" anchor="b">
+                    <a:lnL>
+                      <a:noFill/>
+                    </a:lnL>
+                    <a:lnR>
+                      <a:noFill/>
+                    </a:lnR>
+                    <a:lnT>
+                      <a:noFill/>
+                    </a:lnT>
+                    <a:lnB>
+                      <a:noFill/>
+                    </a:lnB>
+                    <a:noFill/>
+                  </a:tcPr>
+                </a:tc>
+                <a:tc>
+                  <a:txBody>
+                    <a:bodyPr/>
+                    <a:lstStyle/>
+                    <a:p>
+                      <a:pPr algn="r" fontAlgn="b"/>
+                      <a:r>
+                        <a:rPr lang="pt-BR" sz="1100" b="0" i="0" u="none" strike="noStrike">
+                          <a:solidFill>
+                            <a:srgbClr val="000000"/>
+                          </a:solidFill>
+                          <a:effectLst/>
+                          <a:latin typeface="Calibri" panose="020F0502020204030204" pitchFamily="34" charset="0"/>
+                        </a:rPr>
+                        <a:t>-1</a:t>
+                      </a:r>
+                    </a:p>
+                  </a:txBody>
+                  <a:tcPr marL="9525" marR="9525" marT="9525" marB="0" anchor="b">
+                    <a:lnL>
+                      <a:noFill/>
+                    </a:lnL>
+                    <a:lnR>
+                      <a:noFill/>
+                    </a:lnR>
+                    <a:lnT>
+                      <a:noFill/>
+                    </a:lnT>
+                    <a:lnB>
+                      <a:noFill/>
+                    </a:lnB>
+                    <a:noFill/>
+                  </a:tcPr>
+                </a:tc>
+                <a:tc>
+                  <a:txBody>
+                    <a:bodyPr/>
+                    <a:lstStyle/>
+                    <a:p>
+                      <a:pPr algn="r" fontAlgn="b"/>
+                      <a:r>
+                        <a:rPr lang="pt-BR" sz="1100" b="0" i="0" u="none" strike="noStrike">
+                          <a:solidFill>
+                            <a:srgbClr val="000000"/>
+                          </a:solidFill>
+                          <a:effectLst/>
+                          <a:latin typeface="Calibri" panose="020F0502020204030204" pitchFamily="34" charset="0"/>
+                        </a:rPr>
+                        <a:t>-1</a:t>
+                      </a:r>
+                    </a:p>
+                  </a:txBody>
+                  <a:tcPr marL="9525" marR="9525" marT="9525" marB="0" anchor="b">
+                    <a:lnL>
+                      <a:noFill/>
+                    </a:lnL>
+                    <a:lnR>
+                      <a:noFill/>
+                    </a:lnR>
+                    <a:lnT>
+                      <a:noFill/>
+                    </a:lnT>
+                    <a:lnB>
+                      <a:noFill/>
+                    </a:lnB>
+                    <a:noFill/>
+                  </a:tcPr>
+                </a:tc>
+                <a:extLst>
+                  <a:ext uri="{0D108BD9-81ED-4DB2-BD59-A6C34878D82A}">
+                    <a16:rowId xmlns:a16="http://schemas.microsoft.com/office/drawing/2014/main" val="1206773183"/>
+                  </a:ext>
+                </a:extLst>
+              </a:tr>
+              <a:tr h="190500">
+                <a:tc>
+                  <a:txBody>
+                    <a:bodyPr/>
+                    <a:lstStyle/>
+                    <a:p>
+                      <a:pPr algn="r" fontAlgn="b"/>
+                      <a:r>
+                        <a:rPr lang="pt-BR" sz="1100" b="0" i="0" u="none" strike="noStrike">
+                          <a:solidFill>
+                            <a:srgbClr val="000000"/>
+                          </a:solidFill>
+                          <a:effectLst/>
+                          <a:latin typeface="Calibri" panose="020F0502020204030204" pitchFamily="34" charset="0"/>
+                        </a:rPr>
+                        <a:t>1</a:t>
+                      </a:r>
+                    </a:p>
+                  </a:txBody>
+                  <a:tcPr marL="9525" marR="9525" marT="9525" marB="0" anchor="b">
+                    <a:lnL>
+                      <a:noFill/>
+                    </a:lnL>
+                    <a:lnR>
+                      <a:noFill/>
+                    </a:lnR>
+                    <a:lnT>
+                      <a:noFill/>
+                    </a:lnT>
+                    <a:lnB>
+                      <a:noFill/>
+                    </a:lnB>
+                    <a:noFill/>
+                  </a:tcPr>
+                </a:tc>
+                <a:tc>
+                  <a:txBody>
+                    <a:bodyPr/>
+                    <a:lstStyle/>
+                    <a:p>
+                      <a:pPr algn="r" fontAlgn="b"/>
+                      <a:r>
+                        <a:rPr lang="pt-BR" sz="1100" b="0" i="0" u="none" strike="noStrike">
+                          <a:solidFill>
+                            <a:srgbClr val="000000"/>
+                          </a:solidFill>
+                          <a:effectLst/>
+                          <a:latin typeface="Calibri" panose="020F0502020204030204" pitchFamily="34" charset="0"/>
+                        </a:rPr>
+                        <a:t>0</a:t>
+                      </a:r>
+                    </a:p>
+                  </a:txBody>
+                  <a:tcPr marL="9525" marR="9525" marT="9525" marB="0" anchor="b">
+                    <a:lnL>
+                      <a:noFill/>
+                    </a:lnL>
+                    <a:lnR>
+                      <a:noFill/>
+                    </a:lnR>
+                    <a:lnT>
+                      <a:noFill/>
+                    </a:lnT>
+                    <a:lnB>
+                      <a:noFill/>
+                    </a:lnB>
+                    <a:noFill/>
+                  </a:tcPr>
+                </a:tc>
+                <a:tc>
+                  <a:txBody>
+                    <a:bodyPr/>
+                    <a:lstStyle/>
+                    <a:p>
+                      <a:pPr algn="r" fontAlgn="b"/>
+                      <a:r>
+                        <a:rPr lang="pt-BR" sz="1100" b="0" i="0" u="none" strike="noStrike">
+                          <a:solidFill>
+                            <a:srgbClr val="000000"/>
+                          </a:solidFill>
+                          <a:effectLst/>
+                          <a:latin typeface="Calibri" panose="020F0502020204030204" pitchFamily="34" charset="0"/>
+                        </a:rPr>
+                        <a:t>1</a:t>
+                      </a:r>
+                    </a:p>
+                  </a:txBody>
+                  <a:tcPr marL="9525" marR="9525" marT="9525" marB="0" anchor="b">
+                    <a:lnL>
+                      <a:noFill/>
+                    </a:lnL>
+                    <a:lnR>
+                      <a:noFill/>
+                    </a:lnR>
+                    <a:lnT>
+                      <a:noFill/>
+                    </a:lnT>
+                    <a:lnB>
+                      <a:noFill/>
+                    </a:lnB>
+                    <a:noFill/>
+                  </a:tcPr>
+                </a:tc>
+                <a:tc>
+                  <a:txBody>
+                    <a:bodyPr/>
+                    <a:lstStyle/>
+                    <a:p>
+                      <a:pPr algn="r" fontAlgn="b"/>
+                      <a:r>
+                        <a:rPr lang="pt-BR" sz="1100" b="0" i="0" u="none" strike="noStrike">
+                          <a:solidFill>
+                            <a:srgbClr val="000000"/>
+                          </a:solidFill>
+                          <a:effectLst/>
+                          <a:latin typeface="Calibri" panose="020F0502020204030204" pitchFamily="34" charset="0"/>
+                        </a:rPr>
+                        <a:t>1</a:t>
+                      </a:r>
+                    </a:p>
+                  </a:txBody>
+                  <a:tcPr marL="9525" marR="9525" marT="9525" marB="0" anchor="b">
+                    <a:lnL>
+                      <a:noFill/>
+                    </a:lnL>
+                    <a:lnR>
+                      <a:noFill/>
+                    </a:lnR>
+                    <a:lnT>
+                      <a:noFill/>
+                    </a:lnT>
+                    <a:lnB>
+                      <a:noFill/>
+                    </a:lnB>
+                    <a:noFill/>
+                  </a:tcPr>
+                </a:tc>
+                <a:tc>
+                  <a:txBody>
+                    <a:bodyPr/>
+                    <a:lstStyle/>
+                    <a:p>
+                      <a:pPr algn="r" fontAlgn="b"/>
+                      <a:r>
+                        <a:rPr lang="pt-BR" sz="1100" b="0" i="0" u="none" strike="noStrike">
+                          <a:solidFill>
+                            <a:srgbClr val="000000"/>
+                          </a:solidFill>
+                          <a:effectLst/>
+                          <a:latin typeface="Calibri" panose="020F0502020204030204" pitchFamily="34" charset="0"/>
+                        </a:rPr>
+                        <a:t>0</a:t>
+                      </a:r>
+                    </a:p>
+                  </a:txBody>
+                  <a:tcPr marL="9525" marR="9525" marT="9525" marB="0" anchor="b">
+                    <a:lnL>
+                      <a:noFill/>
+                    </a:lnL>
+                    <a:lnR>
+                      <a:noFill/>
+                    </a:lnR>
+                    <a:lnT>
+                      <a:noFill/>
+                    </a:lnT>
+                    <a:lnB>
+                      <a:noFill/>
+                    </a:lnB>
+                    <a:noFill/>
+                  </a:tcPr>
+                </a:tc>
+                <a:extLst>
+                  <a:ext uri="{0D108BD9-81ED-4DB2-BD59-A6C34878D82A}">
+                    <a16:rowId xmlns:a16="http://schemas.microsoft.com/office/drawing/2014/main" val="4146426009"/>
+                  </a:ext>
+                </a:extLst>
+              </a:tr>
+              <a:tr h="190500">
+                <a:tc>
+                  <a:txBody>
+                    <a:bodyPr/>
+                    <a:lstStyle/>
+                    <a:p>
+                      <a:pPr algn="r" fontAlgn="b"/>
+                      <a:r>
+                        <a:rPr lang="pt-BR" sz="1100" b="0" i="0" u="none" strike="noStrike">
+                          <a:solidFill>
+                            <a:srgbClr val="000000"/>
+                          </a:solidFill>
+                          <a:effectLst/>
+                          <a:latin typeface="Calibri" panose="020F0502020204030204" pitchFamily="34" charset="0"/>
+                        </a:rPr>
+                        <a:t>1</a:t>
+                      </a:r>
+                    </a:p>
+                  </a:txBody>
+                  <a:tcPr marL="9525" marR="9525" marT="9525" marB="0" anchor="b">
+                    <a:lnL>
+                      <a:noFill/>
+                    </a:lnL>
+                    <a:lnR>
+                      <a:noFill/>
+                    </a:lnR>
+                    <a:lnT>
+                      <a:noFill/>
+                    </a:lnT>
+                    <a:lnB>
+                      <a:noFill/>
+                    </a:lnB>
+                    <a:noFill/>
+                  </a:tcPr>
+                </a:tc>
+                <a:tc>
+                  <a:txBody>
+                    <a:bodyPr/>
+                    <a:lstStyle/>
+                    <a:p>
+                      <a:pPr algn="r" fontAlgn="b"/>
+                      <a:r>
+                        <a:rPr lang="pt-BR" sz="1100" b="0" i="0" u="none" strike="noStrike">
+                          <a:solidFill>
+                            <a:srgbClr val="000000"/>
+                          </a:solidFill>
+                          <a:effectLst/>
+                          <a:latin typeface="Calibri" panose="020F0502020204030204" pitchFamily="34" charset="0"/>
+                        </a:rPr>
+                        <a:t>0</a:t>
+                      </a:r>
+                    </a:p>
+                  </a:txBody>
+                  <a:tcPr marL="9525" marR="9525" marT="9525" marB="0" anchor="b">
+                    <a:lnL>
+                      <a:noFill/>
+                    </a:lnL>
+                    <a:lnR>
+                      <a:noFill/>
+                    </a:lnR>
+                    <a:lnT>
+                      <a:noFill/>
+                    </a:lnT>
+                    <a:lnB>
+                      <a:noFill/>
+                    </a:lnB>
+                    <a:noFill/>
+                  </a:tcPr>
+                </a:tc>
+                <a:tc>
+                  <a:txBody>
+                    <a:bodyPr/>
+                    <a:lstStyle/>
+                    <a:p>
+                      <a:pPr algn="r" fontAlgn="b"/>
+                      <a:r>
+                        <a:rPr lang="pt-BR" sz="1100" b="0" i="0" u="none" strike="noStrike">
+                          <a:solidFill>
+                            <a:srgbClr val="000000"/>
+                          </a:solidFill>
+                          <a:effectLst/>
+                          <a:latin typeface="Calibri" panose="020F0502020204030204" pitchFamily="34" charset="0"/>
+                        </a:rPr>
+                        <a:t>1</a:t>
+                      </a:r>
+                    </a:p>
+                  </a:txBody>
+                  <a:tcPr marL="9525" marR="9525" marT="9525" marB="0" anchor="b">
+                    <a:lnL>
+                      <a:noFill/>
+                    </a:lnL>
+                    <a:lnR>
+                      <a:noFill/>
+                    </a:lnR>
+                    <a:lnT>
+                      <a:noFill/>
+                    </a:lnT>
+                    <a:lnB>
+                      <a:noFill/>
+                    </a:lnB>
+                    <a:noFill/>
+                  </a:tcPr>
+                </a:tc>
+                <a:tc>
+                  <a:txBody>
+                    <a:bodyPr/>
+                    <a:lstStyle/>
+                    <a:p>
+                      <a:pPr algn="r" fontAlgn="b"/>
+                      <a:r>
+                        <a:rPr lang="pt-BR" sz="1100" b="0" i="0" u="none" strike="noStrike">
+                          <a:solidFill>
+                            <a:srgbClr val="000000"/>
+                          </a:solidFill>
+                          <a:effectLst/>
+                          <a:latin typeface="Calibri" panose="020F0502020204030204" pitchFamily="34" charset="0"/>
+                        </a:rPr>
+                        <a:t>1</a:t>
+                      </a:r>
+                    </a:p>
+                  </a:txBody>
+                  <a:tcPr marL="9525" marR="9525" marT="9525" marB="0" anchor="b">
+                    <a:lnL>
+                      <a:noFill/>
+                    </a:lnL>
+                    <a:lnR>
+                      <a:noFill/>
+                    </a:lnR>
+                    <a:lnT>
+                      <a:noFill/>
+                    </a:lnT>
+                    <a:lnB>
+                      <a:noFill/>
+                    </a:lnB>
+                    <a:noFill/>
+                  </a:tcPr>
+                </a:tc>
+                <a:tc>
+                  <a:txBody>
+                    <a:bodyPr/>
+                    <a:lstStyle/>
+                    <a:p>
+                      <a:pPr algn="r" fontAlgn="b"/>
+                      <a:r>
+                        <a:rPr lang="pt-BR" sz="1100" b="0" i="0" u="none" strike="noStrike">
+                          <a:solidFill>
+                            <a:srgbClr val="000000"/>
+                          </a:solidFill>
+                          <a:effectLst/>
+                          <a:latin typeface="Calibri" panose="020F0502020204030204" pitchFamily="34" charset="0"/>
+                        </a:rPr>
+                        <a:t>0</a:t>
+                      </a:r>
+                    </a:p>
+                  </a:txBody>
+                  <a:tcPr marL="9525" marR="9525" marT="9525" marB="0" anchor="b">
+                    <a:lnL>
+                      <a:noFill/>
+                    </a:lnL>
+                    <a:lnR>
+                      <a:noFill/>
+                    </a:lnR>
+                    <a:lnT>
+                      <a:noFill/>
+                    </a:lnT>
+                    <a:lnB>
+                      <a:noFill/>
+                    </a:lnB>
+                    <a:noFill/>
+                  </a:tcPr>
+                </a:tc>
+                <a:extLst>
+                  <a:ext uri="{0D108BD9-81ED-4DB2-BD59-A6C34878D82A}">
+                    <a16:rowId xmlns:a16="http://schemas.microsoft.com/office/drawing/2014/main" val="3537405935"/>
+                  </a:ext>
+                </a:extLst>
+              </a:tr>
+              <a:tr h="190500">
+                <a:tc>
+                  <a:txBody>
+                    <a:bodyPr/>
+                    <a:lstStyle/>
+                    <a:p>
+                      <a:pPr algn="l" fontAlgn="b"/>
+                      <a:endParaRPr lang="pt-BR" sz="1100" b="0" i="0" u="none" strike="noStrike">
+                        <a:solidFill>
+                          <a:srgbClr val="000000"/>
+                        </a:solidFill>
+                        <a:effectLst/>
+                        <a:latin typeface="Calibri" panose="020F0502020204030204" pitchFamily="34" charset="0"/>
+                      </a:endParaRPr>
+                    </a:p>
+                  </a:txBody>
+                  <a:tcPr marL="9525" marR="9525" marT="9525" marB="0" anchor="b">
+                    <a:lnL>
+                      <a:noFill/>
+                    </a:lnL>
+                    <a:lnR>
+                      <a:noFill/>
+                    </a:lnR>
+                    <a:lnT>
+                      <a:noFill/>
+                    </a:lnT>
+                    <a:lnB>
+                      <a:noFill/>
+                    </a:lnB>
+                    <a:noFill/>
+                  </a:tcPr>
+                </a:tc>
+                <a:tc>
+                  <a:txBody>
+                    <a:bodyPr/>
+                    <a:lstStyle/>
+                    <a:p>
+                      <a:pPr algn="l" fontAlgn="b"/>
+                      <a:endParaRPr lang="pt-BR" sz="1100" b="0" i="0" u="none" strike="noStrike">
+                        <a:solidFill>
+                          <a:srgbClr val="000000"/>
+                        </a:solidFill>
+                        <a:effectLst/>
+                        <a:latin typeface="Calibri" panose="020F0502020204030204" pitchFamily="34" charset="0"/>
+                      </a:endParaRPr>
+                    </a:p>
+                  </a:txBody>
+                  <a:tcPr marL="9525" marR="9525" marT="9525" marB="0" anchor="b">
+                    <a:lnL>
+                      <a:noFill/>
+                    </a:lnL>
+                    <a:lnR>
+                      <a:noFill/>
+                    </a:lnR>
+                    <a:lnT>
+                      <a:noFill/>
+                    </a:lnT>
+                    <a:lnB>
+                      <a:noFill/>
+                    </a:lnB>
+                    <a:noFill/>
+                  </a:tcPr>
+                </a:tc>
+                <a:tc>
+                  <a:txBody>
+                    <a:bodyPr/>
+                    <a:lstStyle/>
+                    <a:p>
+                      <a:pPr algn="l" fontAlgn="b"/>
+                      <a:endParaRPr lang="pt-BR" sz="1100" b="0" i="0" u="none" strike="noStrike">
+                        <a:solidFill>
+                          <a:srgbClr val="000000"/>
+                        </a:solidFill>
+                        <a:effectLst/>
+                        <a:latin typeface="Calibri" panose="020F0502020204030204" pitchFamily="34" charset="0"/>
+                      </a:endParaRPr>
+                    </a:p>
+                  </a:txBody>
+                  <a:tcPr marL="9525" marR="9525" marT="9525" marB="0" anchor="b">
+                    <a:lnL>
+                      <a:noFill/>
+                    </a:lnL>
+                    <a:lnR>
+                      <a:noFill/>
+                    </a:lnR>
+                    <a:lnT>
+                      <a:noFill/>
+                    </a:lnT>
+                    <a:lnB>
+                      <a:noFill/>
+                    </a:lnB>
+                    <a:noFill/>
+                  </a:tcPr>
+                </a:tc>
+                <a:tc>
+                  <a:txBody>
+                    <a:bodyPr/>
+                    <a:lstStyle/>
+                    <a:p>
+                      <a:pPr algn="l" fontAlgn="b"/>
+                      <a:endParaRPr lang="pt-BR" sz="1100" b="0" i="0" u="none" strike="noStrike">
+                        <a:solidFill>
+                          <a:srgbClr val="000000"/>
+                        </a:solidFill>
+                        <a:effectLst/>
+                        <a:latin typeface="Calibri" panose="020F0502020204030204" pitchFamily="34" charset="0"/>
+                      </a:endParaRPr>
+                    </a:p>
+                  </a:txBody>
+                  <a:tcPr marL="9525" marR="9525" marT="9525" marB="0" anchor="b">
+                    <a:lnL>
+                      <a:noFill/>
+                    </a:lnL>
+                    <a:lnR>
+                      <a:noFill/>
+                    </a:lnR>
+                    <a:lnT>
+                      <a:noFill/>
+                    </a:lnT>
+                    <a:lnB>
+                      <a:noFill/>
+                    </a:lnB>
+                    <a:noFill/>
+                  </a:tcPr>
+                </a:tc>
+                <a:tc>
+                  <a:txBody>
+                    <a:bodyPr/>
+                    <a:lstStyle/>
+                    <a:p>
+                      <a:pPr algn="r" fontAlgn="b"/>
+                      <a:r>
+                        <a:rPr lang="pt-BR" sz="1100" b="0" i="0" u="none" strike="noStrike" dirty="0">
+                          <a:solidFill>
+                            <a:srgbClr val="000000"/>
+                          </a:solidFill>
+                          <a:effectLst/>
+                          <a:latin typeface="Calibri" panose="020F0502020204030204" pitchFamily="34" charset="0"/>
+                        </a:rPr>
+                        <a:t>-1</a:t>
+                      </a:r>
+                    </a:p>
+                  </a:txBody>
+                  <a:tcPr marL="9525" marR="9525" marT="9525" marB="0" anchor="b">
+                    <a:lnL>
+                      <a:noFill/>
+                    </a:lnL>
+                    <a:lnR>
+                      <a:noFill/>
+                    </a:lnR>
+                    <a:lnT>
+                      <a:noFill/>
+                    </a:lnT>
+                    <a:lnB>
+                      <a:noFill/>
+                    </a:lnB>
+                    <a:noFill/>
+                  </a:tcPr>
+                </a:tc>
+                <a:extLst>
+                  <a:ext uri="{0D108BD9-81ED-4DB2-BD59-A6C34878D82A}">
+                    <a16:rowId xmlns:a16="http://schemas.microsoft.com/office/drawing/2014/main" val="3462218703"/>
+                  </a:ext>
+                </a:extLst>
+              </a:tr>
+            </a:tbl>
+          </a:graphicData>
+        </a:graphic>
+      </p:graphicFrame>
     </p:spTree>
     <p:extLst>
       <p:ext uri="{BB962C8B-B14F-4D97-AF65-F5344CB8AC3E}">
@@ -4160,7 +4928,7 @@
         <p:cNvPr id="1" name="">
           <a:extLst>
             <a:ext uri="{FF2B5EF4-FFF2-40B4-BE49-F238E27FC236}">
-              <a16:creationId xmlns:a16="http://schemas.microsoft.com/office/drawing/2014/main" id="{8E2CA35F-9331-5BAE-E99E-1E16C1E45588}"/>
+              <a16:creationId xmlns:a16="http://schemas.microsoft.com/office/drawing/2014/main" id="{6E8ED826-48D6-C9DC-13D4-ED0B1C821973}"/>
             </a:ext>
           </a:extLst>
         </p:cNvPr>
@@ -4180,7 +4948,7 @@
           <p:cNvPr id="12" name="TextBox 11">
             <a:extLst>
               <a:ext uri="{FF2B5EF4-FFF2-40B4-BE49-F238E27FC236}">
-                <a16:creationId xmlns:a16="http://schemas.microsoft.com/office/drawing/2014/main" id="{477CF272-1685-99F2-10F7-D101D1C64A9F}"/>
+                <a16:creationId xmlns:a16="http://schemas.microsoft.com/office/drawing/2014/main" id="{B3E37C0C-FA0B-D742-8A9D-D1E22F0302D6}"/>
               </a:ext>
             </a:extLst>
           </p:cNvPr>
@@ -4189,8 +4957,8 @@
         </p:nvSpPr>
         <p:spPr>
           <a:xfrm>
-            <a:off x="271318" y="110548"/>
-            <a:ext cx="1343638" cy="369332"/>
+            <a:off x="2281187" y="336884"/>
+            <a:ext cx="1169359" cy="369332"/>
           </a:xfrm>
           <a:prstGeom prst="rect">
             <a:avLst/>
@@ -4209,1065 +4977,15 @@
                   <a:srgbClr val="0070C0"/>
                 </a:solidFill>
               </a:rPr>
-              <a:t>CENÁRIO 1</a:t>
-            </a:r>
-          </a:p>
-        </p:txBody>
-      </p:sp>
-      <p:pic>
-        <p:nvPicPr>
-          <p:cNvPr id="6" name="Picture 5">
-            <a:extLst>
-              <a:ext uri="{FF2B5EF4-FFF2-40B4-BE49-F238E27FC236}">
-                <a16:creationId xmlns:a16="http://schemas.microsoft.com/office/drawing/2014/main" id="{F3BACFF8-DA07-128D-AFFE-DD7273025582}"/>
-              </a:ext>
-            </a:extLst>
-          </p:cNvPr>
-          <p:cNvPicPr>
-            <a:picLocks noChangeAspect="1"/>
-          </p:cNvPicPr>
-          <p:nvPr/>
-        </p:nvPicPr>
-        <p:blipFill>
-          <a:blip r:embed="rId2"/>
-          <a:stretch>
-            <a:fillRect/>
-          </a:stretch>
-        </p:blipFill>
-        <p:spPr>
-          <a:xfrm>
-            <a:off x="186162" y="586967"/>
-            <a:ext cx="6134100" cy="1066800"/>
-          </a:xfrm>
-          <a:prstGeom prst="rect">
-            <a:avLst/>
-          </a:prstGeom>
-        </p:spPr>
-      </p:pic>
-      <p:pic>
-        <p:nvPicPr>
-          <p:cNvPr id="10" name="Picture 9">
-            <a:extLst>
-              <a:ext uri="{FF2B5EF4-FFF2-40B4-BE49-F238E27FC236}">
-                <a16:creationId xmlns:a16="http://schemas.microsoft.com/office/drawing/2014/main" id="{302CFB1B-3512-CB92-E279-E25370D5361A}"/>
-              </a:ext>
-            </a:extLst>
-          </p:cNvPr>
-          <p:cNvPicPr>
-            <a:picLocks noChangeAspect="1"/>
-          </p:cNvPicPr>
-          <p:nvPr/>
-        </p:nvPicPr>
-        <p:blipFill>
-          <a:blip r:embed="rId3"/>
-          <a:stretch>
-            <a:fillRect/>
-          </a:stretch>
-        </p:blipFill>
-        <p:spPr>
-          <a:xfrm>
-            <a:off x="96098" y="1653767"/>
-            <a:ext cx="3566692" cy="5223223"/>
-          </a:xfrm>
-          <a:prstGeom prst="rect">
-            <a:avLst/>
-          </a:prstGeom>
-        </p:spPr>
-      </p:pic>
-      <p:pic>
-        <p:nvPicPr>
-          <p:cNvPr id="14" name="Picture 13">
-            <a:extLst>
-              <a:ext uri="{FF2B5EF4-FFF2-40B4-BE49-F238E27FC236}">
-                <a16:creationId xmlns:a16="http://schemas.microsoft.com/office/drawing/2014/main" id="{7DB88346-94E0-88BC-9703-673E0852DCF4}"/>
-              </a:ext>
-            </a:extLst>
-          </p:cNvPr>
-          <p:cNvPicPr>
-            <a:picLocks noChangeAspect="1"/>
-          </p:cNvPicPr>
-          <p:nvPr/>
-        </p:nvPicPr>
-        <p:blipFill>
-          <a:blip r:embed="rId4"/>
-          <a:stretch>
-            <a:fillRect/>
-          </a:stretch>
-        </p:blipFill>
-        <p:spPr>
-          <a:xfrm>
-            <a:off x="3662790" y="1653767"/>
-            <a:ext cx="4057650" cy="3228975"/>
-          </a:xfrm>
-          <a:prstGeom prst="rect">
-            <a:avLst/>
-          </a:prstGeom>
-        </p:spPr>
-      </p:pic>
-      <p:pic>
-        <p:nvPicPr>
-          <p:cNvPr id="16" name="Picture 15">
-            <a:extLst>
-              <a:ext uri="{FF2B5EF4-FFF2-40B4-BE49-F238E27FC236}">
-                <a16:creationId xmlns:a16="http://schemas.microsoft.com/office/drawing/2014/main" id="{417E65B1-7ACD-D64B-2864-CCAC7A9740D4}"/>
-              </a:ext>
-            </a:extLst>
-          </p:cNvPr>
-          <p:cNvPicPr>
-            <a:picLocks noChangeAspect="1"/>
-          </p:cNvPicPr>
-          <p:nvPr/>
-        </p:nvPicPr>
-        <p:blipFill>
-          <a:blip r:embed="rId5"/>
-          <a:stretch>
-            <a:fillRect/>
-          </a:stretch>
-        </p:blipFill>
-        <p:spPr>
-          <a:xfrm>
-            <a:off x="7806165" y="1653767"/>
-            <a:ext cx="3981450" cy="2362200"/>
-          </a:xfrm>
-          <a:prstGeom prst="rect">
-            <a:avLst/>
-          </a:prstGeom>
-        </p:spPr>
-      </p:pic>
-      <p:pic>
-        <p:nvPicPr>
-          <p:cNvPr id="18" name="Picture 17">
-            <a:extLst>
-              <a:ext uri="{FF2B5EF4-FFF2-40B4-BE49-F238E27FC236}">
-                <a16:creationId xmlns:a16="http://schemas.microsoft.com/office/drawing/2014/main" id="{F793426D-D39B-1610-24B5-23BA28855EAD}"/>
-              </a:ext>
-            </a:extLst>
-          </p:cNvPr>
-          <p:cNvPicPr>
-            <a:picLocks noChangeAspect="1"/>
-          </p:cNvPicPr>
-          <p:nvPr/>
-        </p:nvPicPr>
-        <p:blipFill>
-          <a:blip r:embed="rId6"/>
-          <a:stretch>
-            <a:fillRect/>
-          </a:stretch>
-        </p:blipFill>
-        <p:spPr>
-          <a:xfrm>
-            <a:off x="7720440" y="4015967"/>
-            <a:ext cx="4076700" cy="1390650"/>
-          </a:xfrm>
-          <a:prstGeom prst="rect">
-            <a:avLst/>
-          </a:prstGeom>
-        </p:spPr>
-      </p:pic>
+              <a:t>RISCO TX</a:t>
+            </a:r>
+          </a:p>
+        </p:txBody>
+      </p:sp>
     </p:spTree>
     <p:extLst>
       <p:ext uri="{BB962C8B-B14F-4D97-AF65-F5344CB8AC3E}">
-        <p14:creationId xmlns:p14="http://schemas.microsoft.com/office/powerpoint/2010/main" val="1106815609"/>
-      </p:ext>
-    </p:extLst>
-  </p:cSld>
-  <p:clrMapOvr>
-    <a:masterClrMapping/>
-  </p:clrMapOvr>
-</p:sld>
-</file>
-
-<file path=ppt/slides/slide3.xml><?xml version="1.0" encoding="utf-8"?>
-<p:sld xmlns:a="http://schemas.openxmlformats.org/drawingml/2006/main" xmlns:r="http://schemas.openxmlformats.org/officeDocument/2006/relationships" xmlns:p="http://schemas.openxmlformats.org/presentationml/2006/main">
-  <p:cSld>
-    <p:spTree>
-      <p:nvGrpSpPr>
-        <p:cNvPr id="1" name="">
-          <a:extLst>
-            <a:ext uri="{FF2B5EF4-FFF2-40B4-BE49-F238E27FC236}">
-              <a16:creationId xmlns:a16="http://schemas.microsoft.com/office/drawing/2014/main" id="{3CD19F8A-6135-F7B7-DC6B-F0ABA39DA668}"/>
-            </a:ext>
-          </a:extLst>
-        </p:cNvPr>
-        <p:cNvGrpSpPr/>
-        <p:nvPr/>
-      </p:nvGrpSpPr>
-      <p:grpSpPr>
-        <a:xfrm>
-          <a:off x="0" y="0"/>
-          <a:ext cx="0" cy="0"/>
-          <a:chOff x="0" y="0"/>
-          <a:chExt cx="0" cy="0"/>
-        </a:xfrm>
-      </p:grpSpPr>
-      <p:sp>
-        <p:nvSpPr>
-          <p:cNvPr id="12" name="TextBox 11">
-            <a:extLst>
-              <a:ext uri="{FF2B5EF4-FFF2-40B4-BE49-F238E27FC236}">
-                <a16:creationId xmlns:a16="http://schemas.microsoft.com/office/drawing/2014/main" id="{0FC503EB-D55B-9CAB-BEA8-74846039F3EF}"/>
-              </a:ext>
-            </a:extLst>
-          </p:cNvPr>
-          <p:cNvSpPr txBox="1"/>
-          <p:nvPr/>
-        </p:nvSpPr>
-        <p:spPr>
-          <a:xfrm>
-            <a:off x="271318" y="110548"/>
-            <a:ext cx="1343638" cy="369332"/>
-          </a:xfrm>
-          <a:prstGeom prst="rect">
-            <a:avLst/>
-          </a:prstGeom>
-          <a:noFill/>
-        </p:spPr>
-        <p:txBody>
-          <a:bodyPr wrap="none" rtlCol="0">
-            <a:spAutoFit/>
-          </a:bodyPr>
-          <a:lstStyle/>
-          <a:p>
-            <a:r>
-              <a:rPr lang="pt-BR" b="1" dirty="0">
-                <a:solidFill>
-                  <a:srgbClr val="0070C0"/>
-                </a:solidFill>
-              </a:rPr>
-              <a:t>CENARIO 2</a:t>
-            </a:r>
-          </a:p>
-        </p:txBody>
-      </p:sp>
-      <p:pic>
-        <p:nvPicPr>
-          <p:cNvPr id="11" name="Picture 10">
-            <a:extLst>
-              <a:ext uri="{FF2B5EF4-FFF2-40B4-BE49-F238E27FC236}">
-                <a16:creationId xmlns:a16="http://schemas.microsoft.com/office/drawing/2014/main" id="{8441E7E8-03B1-3B40-CC71-EF5A0BA5D047}"/>
-              </a:ext>
-            </a:extLst>
-          </p:cNvPr>
-          <p:cNvPicPr>
-            <a:picLocks noChangeAspect="1"/>
-          </p:cNvPicPr>
-          <p:nvPr/>
-        </p:nvPicPr>
-        <p:blipFill>
-          <a:blip r:embed="rId2"/>
-          <a:stretch>
-            <a:fillRect/>
-          </a:stretch>
-        </p:blipFill>
-        <p:spPr>
-          <a:xfrm>
-            <a:off x="-79689" y="1929708"/>
-            <a:ext cx="3675456" cy="4953189"/>
-          </a:xfrm>
-          <a:prstGeom prst="rect">
-            <a:avLst/>
-          </a:prstGeom>
-        </p:spPr>
-      </p:pic>
-      <p:pic>
-        <p:nvPicPr>
-          <p:cNvPr id="15" name="Picture 14">
-            <a:extLst>
-              <a:ext uri="{FF2B5EF4-FFF2-40B4-BE49-F238E27FC236}">
-                <a16:creationId xmlns:a16="http://schemas.microsoft.com/office/drawing/2014/main" id="{2F1D7703-0204-CA53-FAD1-46AAE2FC4BF6}"/>
-              </a:ext>
-            </a:extLst>
-          </p:cNvPr>
-          <p:cNvPicPr>
-            <a:picLocks noChangeAspect="1"/>
-          </p:cNvPicPr>
-          <p:nvPr/>
-        </p:nvPicPr>
-        <p:blipFill>
-          <a:blip r:embed="rId3"/>
-          <a:stretch>
-            <a:fillRect/>
-          </a:stretch>
-        </p:blipFill>
-        <p:spPr>
-          <a:xfrm>
-            <a:off x="0" y="691458"/>
-            <a:ext cx="5781675" cy="1238250"/>
-          </a:xfrm>
-          <a:prstGeom prst="rect">
-            <a:avLst/>
-          </a:prstGeom>
-        </p:spPr>
-      </p:pic>
-      <p:pic>
-        <p:nvPicPr>
-          <p:cNvPr id="19" name="Picture 18">
-            <a:extLst>
-              <a:ext uri="{FF2B5EF4-FFF2-40B4-BE49-F238E27FC236}">
-                <a16:creationId xmlns:a16="http://schemas.microsoft.com/office/drawing/2014/main" id="{63573ABC-C8AE-E46B-3FE0-824E62C5FDD3}"/>
-              </a:ext>
-            </a:extLst>
-          </p:cNvPr>
-          <p:cNvPicPr>
-            <a:picLocks noChangeAspect="1"/>
-          </p:cNvPicPr>
-          <p:nvPr/>
-        </p:nvPicPr>
-        <p:blipFill>
-          <a:blip r:embed="rId4"/>
-          <a:stretch>
-            <a:fillRect/>
-          </a:stretch>
-        </p:blipFill>
-        <p:spPr>
-          <a:xfrm>
-            <a:off x="3595767" y="1929708"/>
-            <a:ext cx="4295775" cy="3190875"/>
-          </a:xfrm>
-          <a:prstGeom prst="rect">
-            <a:avLst/>
-          </a:prstGeom>
-        </p:spPr>
-      </p:pic>
-      <p:pic>
-        <p:nvPicPr>
-          <p:cNvPr id="21" name="Picture 20">
-            <a:extLst>
-              <a:ext uri="{FF2B5EF4-FFF2-40B4-BE49-F238E27FC236}">
-                <a16:creationId xmlns:a16="http://schemas.microsoft.com/office/drawing/2014/main" id="{47402DCD-C0A4-AD31-8A0F-C37D622B3B04}"/>
-              </a:ext>
-            </a:extLst>
-          </p:cNvPr>
-          <p:cNvPicPr>
-            <a:picLocks noChangeAspect="1"/>
-          </p:cNvPicPr>
-          <p:nvPr/>
-        </p:nvPicPr>
-        <p:blipFill>
-          <a:blip r:embed="rId5"/>
-          <a:stretch>
-            <a:fillRect/>
-          </a:stretch>
-        </p:blipFill>
-        <p:spPr>
-          <a:xfrm>
-            <a:off x="7705771" y="1929708"/>
-            <a:ext cx="4276725" cy="2371725"/>
-          </a:xfrm>
-          <a:prstGeom prst="rect">
-            <a:avLst/>
-          </a:prstGeom>
-        </p:spPr>
-      </p:pic>
-      <p:pic>
-        <p:nvPicPr>
-          <p:cNvPr id="23" name="Picture 22">
-            <a:extLst>
-              <a:ext uri="{FF2B5EF4-FFF2-40B4-BE49-F238E27FC236}">
-                <a16:creationId xmlns:a16="http://schemas.microsoft.com/office/drawing/2014/main" id="{AC62BCD4-B956-EB24-EE17-0E25E3C48454}"/>
-              </a:ext>
-            </a:extLst>
-          </p:cNvPr>
-          <p:cNvPicPr>
-            <a:picLocks noChangeAspect="1"/>
-          </p:cNvPicPr>
-          <p:nvPr/>
-        </p:nvPicPr>
-        <p:blipFill>
-          <a:blip r:embed="rId6"/>
-          <a:stretch>
-            <a:fillRect/>
-          </a:stretch>
-        </p:blipFill>
-        <p:spPr>
-          <a:xfrm>
-            <a:off x="3595767" y="5033067"/>
-            <a:ext cx="4448175" cy="1133475"/>
-          </a:xfrm>
-          <a:prstGeom prst="rect">
-            <a:avLst/>
-          </a:prstGeom>
-        </p:spPr>
-      </p:pic>
-      <p:pic>
-        <p:nvPicPr>
-          <p:cNvPr id="25" name="Picture 24">
-            <a:extLst>
-              <a:ext uri="{FF2B5EF4-FFF2-40B4-BE49-F238E27FC236}">
-                <a16:creationId xmlns:a16="http://schemas.microsoft.com/office/drawing/2014/main" id="{27D6AB22-948A-88CC-8412-5CC0F86C4E4A}"/>
-              </a:ext>
-            </a:extLst>
-          </p:cNvPr>
-          <p:cNvPicPr>
-            <a:picLocks noChangeAspect="1"/>
-          </p:cNvPicPr>
-          <p:nvPr/>
-        </p:nvPicPr>
-        <p:blipFill>
-          <a:blip r:embed="rId7"/>
-          <a:stretch>
-            <a:fillRect/>
-          </a:stretch>
-        </p:blipFill>
-        <p:spPr>
-          <a:xfrm>
-            <a:off x="8043942" y="4406302"/>
-            <a:ext cx="4314825" cy="1171575"/>
-          </a:xfrm>
-          <a:prstGeom prst="rect">
-            <a:avLst/>
-          </a:prstGeom>
-        </p:spPr>
-      </p:pic>
-    </p:spTree>
-    <p:extLst>
-      <p:ext uri="{BB962C8B-B14F-4D97-AF65-F5344CB8AC3E}">
-        <p14:creationId xmlns:p14="http://schemas.microsoft.com/office/powerpoint/2010/main" val="3804799167"/>
-      </p:ext>
-    </p:extLst>
-  </p:cSld>
-  <p:clrMapOvr>
-    <a:masterClrMapping/>
-  </p:clrMapOvr>
-</p:sld>
-</file>
-
-<file path=ppt/slides/slide4.xml><?xml version="1.0" encoding="utf-8"?>
-<p:sld xmlns:a="http://schemas.openxmlformats.org/drawingml/2006/main" xmlns:r="http://schemas.openxmlformats.org/officeDocument/2006/relationships" xmlns:p="http://schemas.openxmlformats.org/presentationml/2006/main">
-  <p:cSld>
-    <p:spTree>
-      <p:nvGrpSpPr>
-        <p:cNvPr id="1" name="">
-          <a:extLst>
-            <a:ext uri="{FF2B5EF4-FFF2-40B4-BE49-F238E27FC236}">
-              <a16:creationId xmlns:a16="http://schemas.microsoft.com/office/drawing/2014/main" id="{D451C2E7-6C63-7E65-755E-D6E237564BB0}"/>
-            </a:ext>
-          </a:extLst>
-        </p:cNvPr>
-        <p:cNvGrpSpPr/>
-        <p:nvPr/>
-      </p:nvGrpSpPr>
-      <p:grpSpPr>
-        <a:xfrm>
-          <a:off x="0" y="0"/>
-          <a:ext cx="0" cy="0"/>
-          <a:chOff x="0" y="0"/>
-          <a:chExt cx="0" cy="0"/>
-        </a:xfrm>
-      </p:grpSpPr>
-      <p:sp>
-        <p:nvSpPr>
-          <p:cNvPr id="12" name="TextBox 11">
-            <a:extLst>
-              <a:ext uri="{FF2B5EF4-FFF2-40B4-BE49-F238E27FC236}">
-                <a16:creationId xmlns:a16="http://schemas.microsoft.com/office/drawing/2014/main" id="{EBC662AA-EA11-41F8-569C-95F4AC3D2E38}"/>
-              </a:ext>
-            </a:extLst>
-          </p:cNvPr>
-          <p:cNvSpPr txBox="1"/>
-          <p:nvPr/>
-        </p:nvSpPr>
-        <p:spPr>
-          <a:xfrm>
-            <a:off x="244158" y="74334"/>
-            <a:ext cx="1343638" cy="369332"/>
-          </a:xfrm>
-          <a:prstGeom prst="rect">
-            <a:avLst/>
-          </a:prstGeom>
-          <a:noFill/>
-        </p:spPr>
-        <p:txBody>
-          <a:bodyPr wrap="none" rtlCol="0">
-            <a:spAutoFit/>
-          </a:bodyPr>
-          <a:lstStyle/>
-          <a:p>
-            <a:r>
-              <a:rPr lang="pt-BR" b="1" dirty="0">
-                <a:solidFill>
-                  <a:srgbClr val="0070C0"/>
-                </a:solidFill>
-              </a:rPr>
-              <a:t>CENARIO 3</a:t>
-            </a:r>
-          </a:p>
-        </p:txBody>
-      </p:sp>
-      <p:pic>
-        <p:nvPicPr>
-          <p:cNvPr id="5" name="Picture 4">
-            <a:extLst>
-              <a:ext uri="{FF2B5EF4-FFF2-40B4-BE49-F238E27FC236}">
-                <a16:creationId xmlns:a16="http://schemas.microsoft.com/office/drawing/2014/main" id="{B60547CC-428E-6FA0-1014-77EF76AC9510}"/>
-              </a:ext>
-            </a:extLst>
-          </p:cNvPr>
-          <p:cNvPicPr>
-            <a:picLocks noChangeAspect="1"/>
-          </p:cNvPicPr>
-          <p:nvPr/>
-        </p:nvPicPr>
-        <p:blipFill>
-          <a:blip r:embed="rId2"/>
-          <a:stretch>
-            <a:fillRect/>
-          </a:stretch>
-        </p:blipFill>
-        <p:spPr>
-          <a:xfrm>
-            <a:off x="0" y="1496553"/>
-            <a:ext cx="3649321" cy="5361447"/>
-          </a:xfrm>
-          <a:prstGeom prst="rect">
-            <a:avLst/>
-          </a:prstGeom>
-        </p:spPr>
-      </p:pic>
-      <p:pic>
-        <p:nvPicPr>
-          <p:cNvPr id="7" name="Picture 6">
-            <a:extLst>
-              <a:ext uri="{FF2B5EF4-FFF2-40B4-BE49-F238E27FC236}">
-                <a16:creationId xmlns:a16="http://schemas.microsoft.com/office/drawing/2014/main" id="{788645E8-3430-C9E4-99DF-DED45D910663}"/>
-              </a:ext>
-            </a:extLst>
-          </p:cNvPr>
-          <p:cNvPicPr>
-            <a:picLocks noChangeAspect="1"/>
-          </p:cNvPicPr>
-          <p:nvPr/>
-        </p:nvPicPr>
-        <p:blipFill>
-          <a:blip r:embed="rId3"/>
-          <a:stretch>
-            <a:fillRect/>
-          </a:stretch>
-        </p:blipFill>
-        <p:spPr>
-          <a:xfrm>
-            <a:off x="3567363" y="1496553"/>
-            <a:ext cx="4191000" cy="3219450"/>
-          </a:xfrm>
-          <a:prstGeom prst="rect">
-            <a:avLst/>
-          </a:prstGeom>
-        </p:spPr>
-      </p:pic>
-      <p:pic>
-        <p:nvPicPr>
-          <p:cNvPr id="9" name="Picture 8">
-            <a:extLst>
-              <a:ext uri="{FF2B5EF4-FFF2-40B4-BE49-F238E27FC236}">
-                <a16:creationId xmlns:a16="http://schemas.microsoft.com/office/drawing/2014/main" id="{E5A7528A-4D94-8349-29F0-D6D3E568871F}"/>
-              </a:ext>
-            </a:extLst>
-          </p:cNvPr>
-          <p:cNvPicPr>
-            <a:picLocks noChangeAspect="1"/>
-          </p:cNvPicPr>
-          <p:nvPr/>
-        </p:nvPicPr>
-        <p:blipFill>
-          <a:blip r:embed="rId4"/>
-          <a:stretch>
-            <a:fillRect/>
-          </a:stretch>
-        </p:blipFill>
-        <p:spPr>
-          <a:xfrm>
-            <a:off x="244158" y="396143"/>
-            <a:ext cx="4837981" cy="1106052"/>
-          </a:xfrm>
-          <a:prstGeom prst="rect">
-            <a:avLst/>
-          </a:prstGeom>
-        </p:spPr>
-      </p:pic>
-      <p:pic>
-        <p:nvPicPr>
-          <p:cNvPr id="13" name="Picture 12">
-            <a:extLst>
-              <a:ext uri="{FF2B5EF4-FFF2-40B4-BE49-F238E27FC236}">
-                <a16:creationId xmlns:a16="http://schemas.microsoft.com/office/drawing/2014/main" id="{2987115C-D42E-1A76-F416-3675F6182702}"/>
-              </a:ext>
-            </a:extLst>
-          </p:cNvPr>
-          <p:cNvPicPr>
-            <a:picLocks noChangeAspect="1"/>
-          </p:cNvPicPr>
-          <p:nvPr/>
-        </p:nvPicPr>
-        <p:blipFill>
-          <a:blip r:embed="rId5"/>
-          <a:stretch>
-            <a:fillRect/>
-          </a:stretch>
-        </p:blipFill>
-        <p:spPr>
-          <a:xfrm>
-            <a:off x="7758363" y="1496553"/>
-            <a:ext cx="4171950" cy="2133600"/>
-          </a:xfrm>
-          <a:prstGeom prst="rect">
-            <a:avLst/>
-          </a:prstGeom>
-        </p:spPr>
-      </p:pic>
-    </p:spTree>
-    <p:extLst>
-      <p:ext uri="{BB962C8B-B14F-4D97-AF65-F5344CB8AC3E}">
-        <p14:creationId xmlns:p14="http://schemas.microsoft.com/office/powerpoint/2010/main" val="855907889"/>
-      </p:ext>
-    </p:extLst>
-  </p:cSld>
-  <p:clrMapOvr>
-    <a:masterClrMapping/>
-  </p:clrMapOvr>
-</p:sld>
-</file>
-
-<file path=ppt/slides/slide5.xml><?xml version="1.0" encoding="utf-8"?>
-<p:sld xmlns:a="http://schemas.openxmlformats.org/drawingml/2006/main" xmlns:r="http://schemas.openxmlformats.org/officeDocument/2006/relationships" xmlns:p="http://schemas.openxmlformats.org/presentationml/2006/main">
-  <p:cSld>
-    <p:spTree>
-      <p:nvGrpSpPr>
-        <p:cNvPr id="1" name="">
-          <a:extLst>
-            <a:ext uri="{FF2B5EF4-FFF2-40B4-BE49-F238E27FC236}">
-              <a16:creationId xmlns:a16="http://schemas.microsoft.com/office/drawing/2014/main" id="{41226DE6-3251-B1A9-D13E-388C6F7E168E}"/>
-            </a:ext>
-          </a:extLst>
-        </p:cNvPr>
-        <p:cNvGrpSpPr/>
-        <p:nvPr/>
-      </p:nvGrpSpPr>
-      <p:grpSpPr>
-        <a:xfrm>
-          <a:off x="0" y="0"/>
-          <a:ext cx="0" cy="0"/>
-          <a:chOff x="0" y="0"/>
-          <a:chExt cx="0" cy="0"/>
-        </a:xfrm>
-      </p:grpSpPr>
-      <p:sp>
-        <p:nvSpPr>
-          <p:cNvPr id="12" name="TextBox 11">
-            <a:extLst>
-              <a:ext uri="{FF2B5EF4-FFF2-40B4-BE49-F238E27FC236}">
-                <a16:creationId xmlns:a16="http://schemas.microsoft.com/office/drawing/2014/main" id="{3720515B-F413-DDE4-B689-0399D1EB13D3}"/>
-              </a:ext>
-            </a:extLst>
-          </p:cNvPr>
-          <p:cNvSpPr txBox="1"/>
-          <p:nvPr/>
-        </p:nvSpPr>
-        <p:spPr>
-          <a:xfrm>
-            <a:off x="244158" y="74334"/>
-            <a:ext cx="1343638" cy="369332"/>
-          </a:xfrm>
-          <a:prstGeom prst="rect">
-            <a:avLst/>
-          </a:prstGeom>
-          <a:noFill/>
-        </p:spPr>
-        <p:txBody>
-          <a:bodyPr wrap="none" rtlCol="0">
-            <a:spAutoFit/>
-          </a:bodyPr>
-          <a:lstStyle/>
-          <a:p>
-            <a:r>
-              <a:rPr lang="pt-BR" b="1" dirty="0">
-                <a:solidFill>
-                  <a:srgbClr val="0070C0"/>
-                </a:solidFill>
-              </a:rPr>
-              <a:t>CENARIO 4</a:t>
-            </a:r>
-          </a:p>
-        </p:txBody>
-      </p:sp>
-      <p:pic>
-        <p:nvPicPr>
-          <p:cNvPr id="3" name="Picture 2">
-            <a:extLst>
-              <a:ext uri="{FF2B5EF4-FFF2-40B4-BE49-F238E27FC236}">
-                <a16:creationId xmlns:a16="http://schemas.microsoft.com/office/drawing/2014/main" id="{ED13EBEE-931F-9D9F-D2D0-FB4ECD677EAF}"/>
-              </a:ext>
-            </a:extLst>
-          </p:cNvPr>
-          <p:cNvPicPr>
-            <a:picLocks noChangeAspect="1"/>
-          </p:cNvPicPr>
-          <p:nvPr/>
-        </p:nvPicPr>
-        <p:blipFill>
-          <a:blip r:embed="rId2"/>
-          <a:stretch>
-            <a:fillRect/>
-          </a:stretch>
-        </p:blipFill>
-        <p:spPr>
-          <a:xfrm>
-            <a:off x="3408898" y="1871061"/>
-            <a:ext cx="4257675" cy="1171575"/>
-          </a:xfrm>
-          <a:prstGeom prst="rect">
-            <a:avLst/>
-          </a:prstGeom>
-        </p:spPr>
-      </p:pic>
-      <p:pic>
-        <p:nvPicPr>
-          <p:cNvPr id="6" name="Picture 5">
-            <a:extLst>
-              <a:ext uri="{FF2B5EF4-FFF2-40B4-BE49-F238E27FC236}">
-                <a16:creationId xmlns:a16="http://schemas.microsoft.com/office/drawing/2014/main" id="{F75F312B-4308-0B97-AD8A-A4C3165F2622}"/>
-              </a:ext>
-            </a:extLst>
-          </p:cNvPr>
-          <p:cNvPicPr>
-            <a:picLocks noChangeAspect="1"/>
-          </p:cNvPicPr>
-          <p:nvPr/>
-        </p:nvPicPr>
-        <p:blipFill>
-          <a:blip r:embed="rId3"/>
-          <a:stretch>
-            <a:fillRect/>
-          </a:stretch>
-        </p:blipFill>
-        <p:spPr>
-          <a:xfrm>
-            <a:off x="120015" y="443666"/>
-            <a:ext cx="5734050" cy="1314450"/>
-          </a:xfrm>
-          <a:prstGeom prst="rect">
-            <a:avLst/>
-          </a:prstGeom>
-        </p:spPr>
-      </p:pic>
-      <p:pic>
-        <p:nvPicPr>
-          <p:cNvPr id="10" name="Picture 9">
-            <a:extLst>
-              <a:ext uri="{FF2B5EF4-FFF2-40B4-BE49-F238E27FC236}">
-                <a16:creationId xmlns:a16="http://schemas.microsoft.com/office/drawing/2014/main" id="{AF6C5A74-D7DF-D075-427A-7925DC0939E1}"/>
-              </a:ext>
-            </a:extLst>
-          </p:cNvPr>
-          <p:cNvPicPr>
-            <a:picLocks noChangeAspect="1"/>
-          </p:cNvPicPr>
-          <p:nvPr/>
-        </p:nvPicPr>
-        <p:blipFill>
-          <a:blip r:embed="rId4"/>
-          <a:stretch>
-            <a:fillRect/>
-          </a:stretch>
-        </p:blipFill>
-        <p:spPr>
-          <a:xfrm>
-            <a:off x="120015" y="1794712"/>
-            <a:ext cx="3178576" cy="4818896"/>
-          </a:xfrm>
-          <a:prstGeom prst="rect">
-            <a:avLst/>
-          </a:prstGeom>
-        </p:spPr>
-      </p:pic>
-      <p:pic>
-        <p:nvPicPr>
-          <p:cNvPr id="14" name="Picture 13">
-            <a:extLst>
-              <a:ext uri="{FF2B5EF4-FFF2-40B4-BE49-F238E27FC236}">
-                <a16:creationId xmlns:a16="http://schemas.microsoft.com/office/drawing/2014/main" id="{E21FA143-1C33-5D20-B284-29A4BA5B8A43}"/>
-              </a:ext>
-            </a:extLst>
-          </p:cNvPr>
-          <p:cNvPicPr>
-            <a:picLocks noChangeAspect="1"/>
-          </p:cNvPicPr>
-          <p:nvPr/>
-        </p:nvPicPr>
-        <p:blipFill>
-          <a:blip r:embed="rId5"/>
-          <a:stretch>
-            <a:fillRect/>
-          </a:stretch>
-        </p:blipFill>
-        <p:spPr>
-          <a:xfrm>
-            <a:off x="3408898" y="3155581"/>
-            <a:ext cx="4038600" cy="2962275"/>
-          </a:xfrm>
-          <a:prstGeom prst="rect">
-            <a:avLst/>
-          </a:prstGeom>
-        </p:spPr>
-      </p:pic>
-      <p:pic>
-        <p:nvPicPr>
-          <p:cNvPr id="16" name="Picture 15">
-            <a:extLst>
-              <a:ext uri="{FF2B5EF4-FFF2-40B4-BE49-F238E27FC236}">
-                <a16:creationId xmlns:a16="http://schemas.microsoft.com/office/drawing/2014/main" id="{858EC349-03DA-F268-DB17-7602FFCEF128}"/>
-              </a:ext>
-            </a:extLst>
-          </p:cNvPr>
-          <p:cNvPicPr>
-            <a:picLocks noChangeAspect="1"/>
-          </p:cNvPicPr>
-          <p:nvPr/>
-        </p:nvPicPr>
-        <p:blipFill>
-          <a:blip r:embed="rId6"/>
-          <a:stretch>
-            <a:fillRect/>
-          </a:stretch>
-        </p:blipFill>
-        <p:spPr>
-          <a:xfrm>
-            <a:off x="7557805" y="3889658"/>
-            <a:ext cx="4248150" cy="2190750"/>
-          </a:xfrm>
-          <a:prstGeom prst="rect">
-            <a:avLst/>
-          </a:prstGeom>
-        </p:spPr>
-      </p:pic>
-    </p:spTree>
-    <p:extLst>
-      <p:ext uri="{BB962C8B-B14F-4D97-AF65-F5344CB8AC3E}">
-        <p14:creationId xmlns:p14="http://schemas.microsoft.com/office/powerpoint/2010/main" val="652017484"/>
-      </p:ext>
-    </p:extLst>
-  </p:cSld>
-  <p:clrMapOvr>
-    <a:masterClrMapping/>
-  </p:clrMapOvr>
-</p:sld>
-</file>
-
-<file path=ppt/slides/slide6.xml><?xml version="1.0" encoding="utf-8"?>
-<p:sld xmlns:a="http://schemas.openxmlformats.org/drawingml/2006/main" xmlns:r="http://schemas.openxmlformats.org/officeDocument/2006/relationships" xmlns:p="http://schemas.openxmlformats.org/presentationml/2006/main">
-  <p:cSld>
-    <p:spTree>
-      <p:nvGrpSpPr>
-        <p:cNvPr id="1" name="">
-          <a:extLst>
-            <a:ext uri="{FF2B5EF4-FFF2-40B4-BE49-F238E27FC236}">
-              <a16:creationId xmlns:a16="http://schemas.microsoft.com/office/drawing/2014/main" id="{4BF0591C-F0D2-011A-A7F5-C0FEC0189C47}"/>
-            </a:ext>
-          </a:extLst>
-        </p:cNvPr>
-        <p:cNvGrpSpPr/>
-        <p:nvPr/>
-      </p:nvGrpSpPr>
-      <p:grpSpPr>
-        <a:xfrm>
-          <a:off x="0" y="0"/>
-          <a:ext cx="0" cy="0"/>
-          <a:chOff x="0" y="0"/>
-          <a:chExt cx="0" cy="0"/>
-        </a:xfrm>
-      </p:grpSpPr>
-      <p:sp>
-        <p:nvSpPr>
-          <p:cNvPr id="12" name="TextBox 11">
-            <a:extLst>
-              <a:ext uri="{FF2B5EF4-FFF2-40B4-BE49-F238E27FC236}">
-                <a16:creationId xmlns:a16="http://schemas.microsoft.com/office/drawing/2014/main" id="{00D8BAD3-2FB9-3AB5-D8E0-C92888E9CADE}"/>
-              </a:ext>
-            </a:extLst>
-          </p:cNvPr>
-          <p:cNvSpPr txBox="1"/>
-          <p:nvPr/>
-        </p:nvSpPr>
-        <p:spPr>
-          <a:xfrm>
-            <a:off x="244158" y="74334"/>
-            <a:ext cx="1343638" cy="369332"/>
-          </a:xfrm>
-          <a:prstGeom prst="rect">
-            <a:avLst/>
-          </a:prstGeom>
-          <a:noFill/>
-        </p:spPr>
-        <p:txBody>
-          <a:bodyPr wrap="none" rtlCol="0">
-            <a:spAutoFit/>
-          </a:bodyPr>
-          <a:lstStyle/>
-          <a:p>
-            <a:r>
-              <a:rPr lang="pt-BR" b="1" dirty="0">
-                <a:solidFill>
-                  <a:srgbClr val="0070C0"/>
-                </a:solidFill>
-              </a:rPr>
-              <a:t>CENARIO 5</a:t>
-            </a:r>
-          </a:p>
-        </p:txBody>
-      </p:sp>
-      <p:pic>
-        <p:nvPicPr>
-          <p:cNvPr id="4" name="Picture 3">
-            <a:extLst>
-              <a:ext uri="{FF2B5EF4-FFF2-40B4-BE49-F238E27FC236}">
-                <a16:creationId xmlns:a16="http://schemas.microsoft.com/office/drawing/2014/main" id="{2B44CFB2-13EE-23F3-1C59-581FFE62E465}"/>
-              </a:ext>
-            </a:extLst>
-          </p:cNvPr>
-          <p:cNvPicPr>
-            <a:picLocks noChangeAspect="1"/>
-          </p:cNvPicPr>
-          <p:nvPr/>
-        </p:nvPicPr>
-        <p:blipFill>
-          <a:blip r:embed="rId2"/>
-          <a:stretch>
-            <a:fillRect/>
-          </a:stretch>
-        </p:blipFill>
-        <p:spPr>
-          <a:xfrm>
-            <a:off x="120015" y="556611"/>
-            <a:ext cx="5667375" cy="1219200"/>
-          </a:xfrm>
-          <a:prstGeom prst="rect">
-            <a:avLst/>
-          </a:prstGeom>
-        </p:spPr>
-      </p:pic>
-      <p:pic>
-        <p:nvPicPr>
-          <p:cNvPr id="7" name="Picture 6">
-            <a:extLst>
-              <a:ext uri="{FF2B5EF4-FFF2-40B4-BE49-F238E27FC236}">
-                <a16:creationId xmlns:a16="http://schemas.microsoft.com/office/drawing/2014/main" id="{D099B755-B7A0-0791-73C7-03ACC1136CA7}"/>
-              </a:ext>
-            </a:extLst>
-          </p:cNvPr>
-          <p:cNvPicPr>
-            <a:picLocks noChangeAspect="1"/>
-          </p:cNvPicPr>
-          <p:nvPr/>
-        </p:nvPicPr>
-        <p:blipFill>
-          <a:blip r:embed="rId3"/>
-          <a:stretch>
-            <a:fillRect/>
-          </a:stretch>
-        </p:blipFill>
-        <p:spPr>
-          <a:xfrm>
-            <a:off x="120015" y="1888756"/>
-            <a:ext cx="3087518" cy="4868779"/>
-          </a:xfrm>
-          <a:prstGeom prst="rect">
-            <a:avLst/>
-          </a:prstGeom>
-        </p:spPr>
-      </p:pic>
-      <p:pic>
-        <p:nvPicPr>
-          <p:cNvPr id="9" name="Picture 8">
-            <a:extLst>
-              <a:ext uri="{FF2B5EF4-FFF2-40B4-BE49-F238E27FC236}">
-                <a16:creationId xmlns:a16="http://schemas.microsoft.com/office/drawing/2014/main" id="{5B7FE01D-CD13-A1D6-3759-40CE8A5A36FA}"/>
-              </a:ext>
-            </a:extLst>
-          </p:cNvPr>
-          <p:cNvPicPr>
-            <a:picLocks noChangeAspect="1"/>
-          </p:cNvPicPr>
-          <p:nvPr/>
-        </p:nvPicPr>
-        <p:blipFill>
-          <a:blip r:embed="rId4"/>
-          <a:stretch>
-            <a:fillRect/>
-          </a:stretch>
-        </p:blipFill>
-        <p:spPr>
-          <a:xfrm>
-            <a:off x="3342223" y="1888756"/>
-            <a:ext cx="4105275" cy="752475"/>
-          </a:xfrm>
-          <a:prstGeom prst="rect">
-            <a:avLst/>
-          </a:prstGeom>
-        </p:spPr>
-      </p:pic>
-      <p:pic>
-        <p:nvPicPr>
-          <p:cNvPr id="13" name="Picture 12">
-            <a:extLst>
-              <a:ext uri="{FF2B5EF4-FFF2-40B4-BE49-F238E27FC236}">
-                <a16:creationId xmlns:a16="http://schemas.microsoft.com/office/drawing/2014/main" id="{75C77D93-4C28-1087-2101-FC61DB3FEBDD}"/>
-              </a:ext>
-            </a:extLst>
-          </p:cNvPr>
-          <p:cNvPicPr>
-            <a:picLocks noChangeAspect="1"/>
-          </p:cNvPicPr>
-          <p:nvPr/>
-        </p:nvPicPr>
-        <p:blipFill>
-          <a:blip r:embed="rId5"/>
-          <a:stretch>
-            <a:fillRect/>
-          </a:stretch>
-        </p:blipFill>
-        <p:spPr>
-          <a:xfrm>
-            <a:off x="3345431" y="2858702"/>
-            <a:ext cx="3297394" cy="2469281"/>
-          </a:xfrm>
-          <a:prstGeom prst="rect">
-            <a:avLst/>
-          </a:prstGeom>
-        </p:spPr>
-      </p:pic>
-      <p:pic>
-        <p:nvPicPr>
-          <p:cNvPr id="17" name="Picture 16">
-            <a:extLst>
-              <a:ext uri="{FF2B5EF4-FFF2-40B4-BE49-F238E27FC236}">
-                <a16:creationId xmlns:a16="http://schemas.microsoft.com/office/drawing/2014/main" id="{57CF04C9-8613-3E87-2D8B-0B7AEDDBE112}"/>
-              </a:ext>
-            </a:extLst>
-          </p:cNvPr>
-          <p:cNvPicPr>
-            <a:picLocks noChangeAspect="1"/>
-          </p:cNvPicPr>
-          <p:nvPr/>
-        </p:nvPicPr>
-        <p:blipFill>
-          <a:blip r:embed="rId6"/>
-          <a:stretch>
-            <a:fillRect/>
-          </a:stretch>
-        </p:blipFill>
-        <p:spPr>
-          <a:xfrm>
-            <a:off x="6917456" y="2858702"/>
-            <a:ext cx="4286250" cy="2143125"/>
-          </a:xfrm>
-          <a:prstGeom prst="rect">
-            <a:avLst/>
-          </a:prstGeom>
-        </p:spPr>
-      </p:pic>
-    </p:spTree>
-    <p:extLst>
-      <p:ext uri="{BB962C8B-B14F-4D97-AF65-F5344CB8AC3E}">
-        <p14:creationId xmlns:p14="http://schemas.microsoft.com/office/powerpoint/2010/main" val="2899868402"/>
+        <p14:creationId xmlns:p14="http://schemas.microsoft.com/office/powerpoint/2010/main" val="3310696631"/>
       </p:ext>
     </p:extLst>
   </p:cSld>

</xml_diff>